<commit_message>
seminar: slides PUC v0.4-gold (576 pares, metodologia, diagrama)
Atualiza PPTX+PDF do seminário: v0.4-gold, slide de metodologia,
funil +100 realismo, arquitetura com logos sem banner FINAL.
</commit_message>
<xml_diff>
--- a/seminar/CYLAB_SEMINARIO_PUC.pptx
+++ b/seminar/CYLAB_SEMINARIO_PUC.pptx
@@ -13,12 +13,13 @@
     <p:sldId id="267" r:id="rId13"/>
     <p:sldId id="257" r:id="rId3"/>
     <p:sldId id="263" r:id="rId9"/>
+    <p:sldId id="273" r:id="rId24"/>
     <p:sldId id="265" r:id="rId11"/>
     <p:sldId id="269" r:id="rId15"/>
     <p:sldId id="268" r:id="rId14"/>
     <p:sldId id="261" r:id="rId7"/>
     <p:sldId id="272" r:id="rId23"/>
-    <p:sldId id="273" r:id="rId24"/>
+    <p:sldId id="274" r:id="rId25"/>
     <p:sldId id="262" r:id="rId8"/>
     <p:sldId id="258" r:id="rId4"/>
   </p:sldIdLst>
@@ -1085,6 +1086,94 @@
 </file>
 
 <file path=ppt/notesSlides/notesSlide18.xml><?xml version="1.0" encoding="utf-8"?>
+<p:notes xmlns:a="http://schemas.openxmlformats.org/drawingml/2006/main" xmlns:r="http://schemas.openxmlformats.org/officeDocument/2006/relationships" xmlns:p="http://schemas.openxmlformats.org/presentationml/2006/main">
+  <p:cSld>
+    <p:spTree>
+      <p:nvGrpSpPr>
+        <p:cNvPr id="1" name=""/>
+        <p:cNvGrpSpPr/>
+        <p:nvPr/>
+      </p:nvGrpSpPr>
+      <p:grpSpPr>
+        <a:xfrm>
+          <a:off x="0" y="0"/>
+          <a:ext cx="0" cy="0"/>
+          <a:chOff x="0" y="0"/>
+          <a:chExt cx="0" cy="0"/>
+        </a:xfrm>
+      </p:grpSpPr>
+      <p:sp>
+        <p:nvSpPr>
+          <p:cNvPr id="2" name="Slide Image Placeholder 1"/>
+          <p:cNvSpPr>
+            <a:spLocks noGrp="1" noRot="1" noChangeAspect="1"/>
+          </p:cNvSpPr>
+          <p:nvPr>
+            <p:ph type="sldImg"/>
+          </p:nvPr>
+        </p:nvSpPr>
+        <p:spPr/>
+      </p:sp>
+      <p:sp>
+        <p:nvSpPr>
+          <p:cNvPr id="3" name="Notes Placeholder 2"/>
+          <p:cNvSpPr>
+            <a:spLocks noGrp="1"/>
+          </p:cNvSpPr>
+          <p:nvPr>
+            <p:ph type="body" idx="1"/>
+          </p:nvPr>
+        </p:nvSpPr>
+        <p:spPr/>
+        <p:txBody>
+          <a:bodyPr/>
+          <a:lstStyle/>
+          <a:p>
+            <a:r>
+              <a:rPr lang="en-US" dirty="0"/>
+              <a:t/>
+            </a:r>
+            <a:endParaRPr lang="en-US" dirty="0"/>
+          </a:p>
+        </p:txBody>
+      </p:sp>
+      <p:sp>
+        <p:nvSpPr>
+          <p:cNvPr id="4" name="Slide Number Placeholder 3"/>
+          <p:cNvSpPr>
+            <a:spLocks noGrp="1"/>
+          </p:cNvSpPr>
+          <p:nvPr>
+            <p:ph type="sldNum" sz="quarter" idx="10"/>
+          </p:nvPr>
+        </p:nvSpPr>
+        <p:spPr/>
+        <p:txBody>
+          <a:bodyPr/>
+          <a:lstStyle/>
+          <a:p>
+            <a:fld id="{F7021451-1387-4CA6-816F-3879F97B5CBC}" type="slidenum">
+              <a:rPr lang="en-US"/>
+              <a:t>12</a:t>
+            </a:fld>
+            <a:endParaRPr lang="en-US"/>
+          </a:p>
+        </p:txBody>
+      </p:sp>
+    </p:spTree>
+    <p:extLst>
+      <p:ext uri="{BB962C8B-B14F-4D97-AF65-F5344CB8AC3E}">
+        <p14:creationId xmlns:p14="http://schemas.microsoft.com/office/powerpoint/2010/main" val="1024086991"/>
+      </p:ext>
+    </p:extLst>
+  </p:cSld>
+  <p:clrMapOvr>
+    <a:masterClrMapping/>
+  </p:clrMapOvr>
+</p:notes>
+</file>
+
+<file path=ppt/notesSlides/notesSlide19.xml><?xml version="1.0" encoding="utf-8"?>
 <p:notes xmlns:a="http://schemas.openxmlformats.org/drawingml/2006/main" xmlns:r="http://schemas.openxmlformats.org/officeDocument/2006/relationships" xmlns:p="http://schemas.openxmlformats.org/presentationml/2006/main">
   <p:cSld>
     <p:spTree>
@@ -2144,7 +2233,7 @@
                 <a:ea typeface="Poppins" pitchFamily="34" charset="-122"/>
                 <a:cs typeface="Poppins" pitchFamily="34" charset="-120"/>
               </a:rPr>
-              <a:t>Assistente open-source de segurança de código, 100% local. Primeira entrega: arquitetura híbrida e dataset ouro v0.3-gold.</a:t>
+              <a:t>Assistente open-source de segurança de código, 100% local. Primeira entrega: arquitetura híbrida e dataset ouro v0.4-gold, com 576 pares.</a:t>
             </a:r>
             <a:endParaRPr lang="en-US" sz="1200" dirty="0"/>
           </a:p>
@@ -2292,7 +2381,7 @@
                 <a:ea typeface="Poppins" pitchFamily="34" charset="-122"/>
                 <a:cs typeface="Poppins" pitchFamily="34" charset="-120"/>
               </a:rPr>
-              <a:t>6</a:t>
+              <a:t>7</a:t>
             </a:r>
             <a:endParaRPr lang="en-US" sz="1200" dirty="0"/>
           </a:p>
@@ -2661,7 +2750,7 @@
                 <a:ea typeface="Lexend" pitchFamily="34" charset="-122"/>
                 <a:cs typeface="Lexend" pitchFamily="34" charset="-120"/>
               </a:rPr>
-              <a:t>476/476</a:t>
+              <a:t>576/576</a:t>
             </a:r>
             <a:endParaRPr lang="en-US" sz="4800" dirty="0"/>
           </a:p>
@@ -2676,7 +2765,7 @@
         <p:spPr>
           <a:xfrm>
             <a:off x="3520440" y="2852928"/>
-            <a:ext cx="3200400" cy="566928"/>
+            <a:ext cx="3200400" cy="822960"/>
           </a:xfrm>
           <a:prstGeom prst="rect">
             <a:avLst/>
@@ -2703,7 +2792,7 @@
                 <a:ea typeface="Poppins" pitchFamily="34" charset="-122"/>
                 <a:cs typeface="Poppins" pitchFamily="34" charset="-120"/>
               </a:rPr>
-              <a:t>pares do v0.3-gold aprovados na nova verificação do gate</a:t>
+              <a:t>pares do v0.4-gold aprovados no gate rules-gold; o v0.3-gold (476, SHA f37e1316…) segue intacto</a:t>
             </a:r>
             <a:endParaRPr lang="en-US" sz="1200" dirty="0"/>
           </a:p>
@@ -2745,7 +2834,7 @@
                 <a:ea typeface="Poppins" pitchFamily="34" charset="-122"/>
                 <a:cs typeface="Poppins" pitchFamily="34" charset="-120"/>
               </a:rPr>
-              <a:t>Aceite(p) se e somente se achados_r(before) ≥ 1 e achados_r(after) = 0. Implementado em scripts/gate_draft.py, que prefere as regras de rules-gold/, e complementado pelo validador de esquema.</a:t>
+              <a:t>Aceite(p) se e somente se achados_r(before) ≥ 1 e achados_r(after) = 0. Implementado em scripts/gate_gold.py, com as regras de rules-gold/, e complementado pelo validador de esquema.</a:t>
             </a:r>
             <a:endParaRPr lang="en-US" sz="1200" dirty="0"/>
           </a:p>
@@ -3481,7 +3570,7 @@
         </p:nvSpPr>
         <p:spPr>
           <a:xfrm>
-            <a:off x="702259" y="978408"/>
+            <a:off x="702259" y="566928"/>
             <a:ext cx="10394899" cy="769010"/>
           </a:xfrm>
           <a:prstGeom prst="rect">
@@ -3523,1054 +3612,30 @@
           </a:p>
         </p:txBody>
       </p:sp>
-      <p:sp>
-        <p:nvSpPr>
-          <p:cNvPr id="60" name="Shape 58"/>
-          <p:cNvSpPr/>
-          <p:nvPr/>
-        </p:nvSpPr>
-        <p:spPr>
-          <a:xfrm>
-            <a:off x="4069080" y="1810512"/>
-            <a:ext cx="1273759" cy="102413"/>
-          </a:xfrm>
-          <a:prstGeom prst="roundRect">
-            <a:avLst>
-              <a:gd name="adj" fmla="val 50000"/>
-            </a:avLst>
-          </a:prstGeom>
-          <a:solidFill>
-            <a:srgbClr val="2E6B57"/>
-          </a:solidFill>
-          <a:ln/>
-        </p:spPr>
-      </p:sp>
-      <p:sp>
-        <p:nvSpPr>
-          <p:cNvPr id="100" name="Diagram box 1"/>
-          <p:cNvSpPr/>
-          <p:nvPr/>
-        </p:nvSpPr>
-        <p:spPr>
-          <a:xfrm>
-            <a:off x="548640" y="2286000"/>
-            <a:ext cx="1563624" cy="1188720"/>
-          </a:xfrm>
-          <a:prstGeom prst="rect">
-            <a:avLst/>
-          </a:prstGeom>
-          <a:solidFill>
-            <a:srgbClr val="CCCCCC"/>
-          </a:solidFill>
-          <a:ln>
-            <a:noFill/>
-          </a:ln>
-        </p:spPr>
-        <p:txBody>
-          <a:bodyPr wrap="square" lIns="91440" rIns="91440" tIns="91440" bIns="91440" rtlCol="0" anchor="ctr">
-            <a:noAutofit/>
-          </a:bodyPr>
-          <a:lstStyle/>
-          <a:p>
-            <a:pPr algn="ctr" indent="0" marL="0">
-              <a:lnSpc>
-                <a:spcPct val="115000"/>
-              </a:lnSpc>
-              <a:spcAft>
-                <a:spcPts val="300"/>
-              </a:spcAft>
-              <a:buNone/>
-            </a:pPr>
-            <a:r>
-              <a:rPr lang="pt-BR" sz="1400" b="1" i="0" dirty="0">
-                <a:solidFill>
-                  <a:srgbClr val="000000"/>
-                </a:solidFill>
-                <a:latin typeface="Lexend"/>
-                <a:ea typeface="Lexend"/>
-                <a:cs typeface="Lexend"/>
-              </a:rPr>
-              <a:t>Código</a:t>
-            </a:r>
-          </a:p>
-          <a:p>
-            <a:pPr algn="ctr" indent="0" marL="0">
-              <a:lnSpc>
-                <a:spcPct val="115000"/>
-              </a:lnSpc>
-              <a:spcAft>
-                <a:spcPts val="0"/>
-              </a:spcAft>
-              <a:buNone/>
-            </a:pPr>
-            <a:r>
-              <a:rPr lang="pt-BR" sz="1050" b="0" i="0" dirty="0">
-                <a:solidFill>
-                  <a:srgbClr val="000000"/>
-                </a:solidFill>
-                <a:latin typeface="Poppins"/>
-                <a:ea typeface="Poppins"/>
-                <a:cs typeface="Poppins"/>
-              </a:rPr>
-              <a:t>trecho do desenvolvedor</a:t>
-            </a:r>
-          </a:p>
-        </p:txBody>
-      </p:sp>
-      <p:sp>
-        <p:nvSpPr>
-          <p:cNvPr id="101" name="Diagram arrow 1"/>
-          <p:cNvSpPr/>
-          <p:nvPr/>
-        </p:nvSpPr>
-        <p:spPr>
-          <a:xfrm>
-            <a:off x="2167128" y="2761488"/>
-            <a:ext cx="219456" cy="237744"/>
-          </a:xfrm>
-          <a:prstGeom prst="rightArrow">
-            <a:avLst/>
-          </a:prstGeom>
-          <a:solidFill>
-            <a:srgbClr val="2E6B57"/>
-          </a:solidFill>
-          <a:ln>
-            <a:noFill/>
-          </a:ln>
-        </p:spPr>
-      </p:sp>
-      <p:sp>
-        <p:nvSpPr>
-          <p:cNvPr id="102" name="Diagram box 2"/>
-          <p:cNvSpPr/>
-          <p:nvPr/>
-        </p:nvSpPr>
-        <p:spPr>
-          <a:xfrm>
-            <a:off x="2441448" y="2286000"/>
-            <a:ext cx="1563624" cy="1188720"/>
-          </a:xfrm>
-          <a:prstGeom prst="rect">
-            <a:avLst/>
-          </a:prstGeom>
-          <a:solidFill>
-            <a:srgbClr val="1F2A27"/>
-          </a:solidFill>
-          <a:ln>
-            <a:noFill/>
-          </a:ln>
-        </p:spPr>
-        <p:txBody>
-          <a:bodyPr wrap="square" lIns="91440" rIns="91440" tIns="91440" bIns="91440" rtlCol="0" anchor="ctr">
-            <a:noAutofit/>
-          </a:bodyPr>
-          <a:lstStyle/>
-          <a:p>
-            <a:pPr algn="ctr" indent="0" marL="0">
-              <a:lnSpc>
-                <a:spcPct val="115000"/>
-              </a:lnSpc>
-              <a:spcAft>
-                <a:spcPts val="300"/>
-              </a:spcAft>
-              <a:buNone/>
-            </a:pPr>
-            <a:r>
-              <a:rPr lang="pt-BR" sz="1400" b="1" i="0" dirty="0">
-                <a:solidFill>
-                  <a:srgbClr val="F5F3EF"/>
-                </a:solidFill>
-                <a:latin typeface="Lexend"/>
-                <a:ea typeface="Lexend"/>
-                <a:cs typeface="Lexend"/>
-              </a:rPr>
-              <a:t>Opengrep</a:t>
-            </a:r>
-          </a:p>
-          <a:p>
-            <a:pPr algn="ctr" indent="0" marL="0">
-              <a:lnSpc>
-                <a:spcPct val="115000"/>
-              </a:lnSpc>
-              <a:spcAft>
-                <a:spcPts val="0"/>
-              </a:spcAft>
-              <a:buNone/>
-            </a:pPr>
-            <a:r>
-              <a:rPr lang="pt-BR" sz="1050" b="0" i="0" dirty="0">
-                <a:solidFill>
-                  <a:srgbClr val="F5F3EF"/>
-                </a:solidFill>
-                <a:latin typeface="Poppins"/>
-                <a:ea typeface="Poppins"/>
-                <a:cs typeface="Poppins"/>
-              </a:rPr>
-              <a:t>regras Cylab · detecta</a:t>
-            </a:r>
-          </a:p>
-        </p:txBody>
-      </p:sp>
-      <p:sp>
-        <p:nvSpPr>
-          <p:cNvPr id="103" name="Diagram arrow 2"/>
-          <p:cNvSpPr/>
-          <p:nvPr/>
-        </p:nvSpPr>
-        <p:spPr>
-          <a:xfrm>
-            <a:off x="4059936" y="2761488"/>
-            <a:ext cx="219456" cy="237744"/>
-          </a:xfrm>
-          <a:prstGeom prst="rightArrow">
-            <a:avLst/>
-          </a:prstGeom>
-          <a:solidFill>
-            <a:srgbClr val="2E6B57"/>
-          </a:solidFill>
-          <a:ln>
-            <a:noFill/>
-          </a:ln>
-        </p:spPr>
-      </p:sp>
-      <p:sp>
-        <p:nvSpPr>
-          <p:cNvPr id="104" name="Diagram box 3"/>
-          <p:cNvSpPr/>
-          <p:nvPr/>
-        </p:nvSpPr>
-        <p:spPr>
-          <a:xfrm>
-            <a:off x="4334256" y="2286000"/>
-            <a:ext cx="1563624" cy="1188720"/>
-          </a:xfrm>
-          <a:prstGeom prst="rect">
-            <a:avLst/>
-          </a:prstGeom>
-          <a:solidFill>
-            <a:srgbClr val="CCCCCC"/>
-          </a:solidFill>
-          <a:ln>
-            <a:noFill/>
-          </a:ln>
-        </p:spPr>
-        <p:txBody>
-          <a:bodyPr wrap="square" lIns="91440" rIns="91440" tIns="91440" bIns="91440" rtlCol="0" anchor="ctr">
-            <a:noAutofit/>
-          </a:bodyPr>
-          <a:lstStyle/>
-          <a:p>
-            <a:pPr algn="ctr" indent="0" marL="0">
-              <a:lnSpc>
-                <a:spcPct val="115000"/>
-              </a:lnSpc>
-              <a:spcAft>
-                <a:spcPts val="300"/>
-              </a:spcAft>
-              <a:buNone/>
-            </a:pPr>
-            <a:r>
-              <a:rPr lang="pt-BR" sz="1400" b="1" i="0" dirty="0">
-                <a:solidFill>
-                  <a:srgbClr val="000000"/>
-                </a:solidFill>
-                <a:latin typeface="Lexend"/>
-                <a:ea typeface="Lexend"/>
-                <a:cs typeface="Lexend"/>
-              </a:rPr>
-              <a:t>Achado</a:t>
-            </a:r>
-          </a:p>
-          <a:p>
-            <a:pPr algn="ctr" indent="0" marL="0">
-              <a:lnSpc>
-                <a:spcPct val="115000"/>
-              </a:lnSpc>
-              <a:spcAft>
-                <a:spcPts val="0"/>
-              </a:spcAft>
-              <a:buNone/>
-            </a:pPr>
-            <a:r>
-              <a:rPr lang="pt-BR" sz="1050" b="0" i="0" dirty="0">
-                <a:solidFill>
-                  <a:srgbClr val="000000"/>
-                </a:solidFill>
-                <a:latin typeface="Poppins"/>
-                <a:ea typeface="Poppins"/>
-                <a:cs typeface="Poppins"/>
-              </a:rPr>
-              <a:t>regra, CWE e trecho</a:t>
-            </a:r>
-          </a:p>
-        </p:txBody>
-      </p:sp>
-      <p:sp>
-        <p:nvSpPr>
-          <p:cNvPr id="105" name="Diagram arrow 3"/>
-          <p:cNvSpPr/>
-          <p:nvPr/>
-        </p:nvSpPr>
-        <p:spPr>
-          <a:xfrm>
-            <a:off x="5952744" y="2761488"/>
-            <a:ext cx="219456" cy="237744"/>
-          </a:xfrm>
-          <a:prstGeom prst="rightArrow">
-            <a:avLst/>
-          </a:prstGeom>
-          <a:solidFill>
-            <a:srgbClr val="2E6B57"/>
-          </a:solidFill>
-          <a:ln>
-            <a:noFill/>
-          </a:ln>
-        </p:spPr>
-      </p:sp>
-      <p:sp>
-        <p:nvSpPr>
-          <p:cNvPr id="106" name="Diagram box 4"/>
-          <p:cNvSpPr/>
-          <p:nvPr/>
-        </p:nvSpPr>
-        <p:spPr>
-          <a:xfrm>
-            <a:off x="6227064" y="2286000"/>
-            <a:ext cx="1563624" cy="1188720"/>
-          </a:xfrm>
-          <a:prstGeom prst="rect">
-            <a:avLst/>
-          </a:prstGeom>
-          <a:solidFill>
-            <a:srgbClr val="2E6B57"/>
-          </a:solidFill>
-          <a:ln>
-            <a:noFill/>
-          </a:ln>
-        </p:spPr>
-        <p:txBody>
-          <a:bodyPr wrap="square" lIns="91440" rIns="91440" tIns="91440" bIns="91440" rtlCol="0" anchor="ctr">
-            <a:noAutofit/>
-          </a:bodyPr>
-          <a:lstStyle/>
-          <a:p>
-            <a:pPr algn="ctr" indent="0" marL="0">
-              <a:lnSpc>
-                <a:spcPct val="115000"/>
-              </a:lnSpc>
-              <a:spcAft>
-                <a:spcPts val="300"/>
-              </a:spcAft>
-              <a:buNone/>
-            </a:pPr>
-            <a:r>
-              <a:rPr lang="pt-BR" sz="1400" b="1" i="0" dirty="0">
-                <a:solidFill>
-                  <a:srgbClr val="F5F3EF"/>
-                </a:solidFill>
-                <a:latin typeface="Lexend"/>
-                <a:ea typeface="Lexend"/>
-                <a:cs typeface="Lexend"/>
-              </a:rPr>
-              <a:t>LLM local</a:t>
-            </a:r>
-          </a:p>
-          <a:p>
-            <a:pPr algn="ctr" indent="0" marL="0">
-              <a:lnSpc>
-                <a:spcPct val="115000"/>
-              </a:lnSpc>
-              <a:spcAft>
-                <a:spcPts val="0"/>
-              </a:spcAft>
-              <a:buNone/>
-            </a:pPr>
-            <a:r>
-              <a:rPr lang="pt-BR" sz="1050" b="0" i="0" dirty="0">
-                <a:solidFill>
-                  <a:srgbClr val="F5F3EF"/>
-                </a:solidFill>
-                <a:latin typeface="Poppins"/>
-                <a:ea typeface="Poppins"/>
-                <a:cs typeface="Poppins"/>
-              </a:rPr>
-              <a:t>explica em pt-BR</a:t>
-            </a:r>
-          </a:p>
-        </p:txBody>
-      </p:sp>
-      <p:sp>
-        <p:nvSpPr>
-          <p:cNvPr id="107" name="Diagram arrow 4"/>
-          <p:cNvSpPr/>
-          <p:nvPr/>
-        </p:nvSpPr>
-        <p:spPr>
-          <a:xfrm>
-            <a:off x="7845552" y="2761488"/>
-            <a:ext cx="219456" cy="237744"/>
-          </a:xfrm>
-          <a:prstGeom prst="rightArrow">
-            <a:avLst/>
-          </a:prstGeom>
-          <a:solidFill>
-            <a:srgbClr val="2E6B57"/>
-          </a:solidFill>
-          <a:ln>
-            <a:noFill/>
-          </a:ln>
-        </p:spPr>
-      </p:sp>
-      <p:sp>
-        <p:nvSpPr>
-          <p:cNvPr id="108" name="Diagram box 5"/>
-          <p:cNvSpPr/>
-          <p:nvPr/>
-        </p:nvSpPr>
-        <p:spPr>
-          <a:xfrm>
-            <a:off x="8119872" y="2286000"/>
-            <a:ext cx="1563624" cy="1188720"/>
-          </a:xfrm>
-          <a:prstGeom prst="rect">
-            <a:avLst/>
-          </a:prstGeom>
-          <a:solidFill>
-            <a:srgbClr val="CCCCCC"/>
-          </a:solidFill>
-          <a:ln>
-            <a:noFill/>
-          </a:ln>
-        </p:spPr>
-        <p:txBody>
-          <a:bodyPr wrap="square" lIns="91440" rIns="91440" tIns="91440" bIns="91440" rtlCol="0" anchor="ctr">
-            <a:noAutofit/>
-          </a:bodyPr>
-          <a:lstStyle/>
-          <a:p>
-            <a:pPr algn="ctr" indent="0" marL="0">
-              <a:lnSpc>
-                <a:spcPct val="115000"/>
-              </a:lnSpc>
-              <a:spcAft>
-                <a:spcPts val="300"/>
-              </a:spcAft>
-              <a:buNone/>
-            </a:pPr>
-            <a:r>
-              <a:rPr lang="pt-BR" sz="1400" b="1" i="0" dirty="0">
-                <a:solidFill>
-                  <a:srgbClr val="000000"/>
-                </a:solidFill>
-                <a:latin typeface="Lexend"/>
-                <a:ea typeface="Lexend"/>
-                <a:cs typeface="Lexend"/>
-              </a:rPr>
-              <a:t>Explicação + patch</a:t>
-            </a:r>
-          </a:p>
-          <a:p>
-            <a:pPr algn="ctr" indent="0" marL="0">
-              <a:lnSpc>
-                <a:spcPct val="115000"/>
-              </a:lnSpc>
-              <a:spcAft>
-                <a:spcPts val="0"/>
-              </a:spcAft>
-              <a:buNone/>
-            </a:pPr>
-            <a:r>
-              <a:rPr lang="pt-BR" sz="1050" b="0" i="0" dirty="0">
-                <a:solidFill>
-                  <a:srgbClr val="000000"/>
-                </a:solidFill>
-                <a:latin typeface="Poppins"/>
-                <a:ea typeface="Poppins"/>
-                <a:cs typeface="Poppins"/>
-              </a:rPr>
-              <a:t>pt-BR + trecho corrigido</a:t>
-            </a:r>
-          </a:p>
-        </p:txBody>
-      </p:sp>
-      <p:sp>
-        <p:nvSpPr>
-          <p:cNvPr id="109" name="Diagram arrow 5"/>
-          <p:cNvSpPr/>
-          <p:nvPr/>
-        </p:nvSpPr>
-        <p:spPr>
-          <a:xfrm>
-            <a:off x="9738360" y="2761488"/>
-            <a:ext cx="219456" cy="237744"/>
-          </a:xfrm>
-          <a:prstGeom prst="rightArrow">
-            <a:avLst/>
-          </a:prstGeom>
-          <a:solidFill>
-            <a:srgbClr val="2E6B57"/>
-          </a:solidFill>
-          <a:ln>
-            <a:noFill/>
-          </a:ln>
-        </p:spPr>
-      </p:sp>
-      <p:sp>
-        <p:nvSpPr>
-          <p:cNvPr id="110" name="Diagram box 6"/>
-          <p:cNvSpPr/>
-          <p:nvPr/>
-        </p:nvSpPr>
-        <p:spPr>
-          <a:xfrm>
-            <a:off x="10012680" y="2286000"/>
-            <a:ext cx="1563624" cy="1188720"/>
-          </a:xfrm>
-          <a:prstGeom prst="rect">
-            <a:avLst/>
-          </a:prstGeom>
-          <a:solidFill>
-            <a:srgbClr val="1F2A27"/>
-          </a:solidFill>
-          <a:ln>
-            <a:noFill/>
-          </a:ln>
-        </p:spPr>
-        <p:txBody>
-          <a:bodyPr wrap="square" lIns="91440" rIns="91440" tIns="91440" bIns="91440" rtlCol="0" anchor="ctr">
-            <a:noAutofit/>
-          </a:bodyPr>
-          <a:lstStyle/>
-          <a:p>
-            <a:pPr algn="ctr" indent="0" marL="0">
-              <a:lnSpc>
-                <a:spcPct val="115000"/>
-              </a:lnSpc>
-              <a:spcAft>
-                <a:spcPts val="300"/>
-              </a:spcAft>
-              <a:buNone/>
-            </a:pPr>
-            <a:r>
-              <a:rPr lang="pt-BR" sz="1400" b="1" i="0" dirty="0">
-                <a:solidFill>
-                  <a:srgbClr val="F5F3EF"/>
-                </a:solidFill>
-                <a:latin typeface="Lexend"/>
-                <a:ea typeface="Lexend"/>
-                <a:cs typeface="Lexend"/>
-              </a:rPr>
-              <a:t>Re-scan Opengrep</a:t>
-            </a:r>
-          </a:p>
-          <a:p>
-            <a:pPr algn="ctr" indent="0" marL="0">
-              <a:lnSpc>
-                <a:spcPct val="115000"/>
-              </a:lnSpc>
-              <a:spcAft>
-                <a:spcPts val="0"/>
-              </a:spcAft>
-              <a:buNone/>
-            </a:pPr>
-            <a:r>
-              <a:rPr lang="pt-BR" sz="1050" b="0" i="0" dirty="0">
-                <a:solidFill>
-                  <a:srgbClr val="F5F3EF"/>
-                </a:solidFill>
-                <a:latin typeface="Poppins"/>
-                <a:ea typeface="Poppins"/>
-                <a:cs typeface="Poppins"/>
-              </a:rPr>
-              <a:t>a regra deve dar 0 achados</a:t>
-            </a:r>
-          </a:p>
-        </p:txBody>
-      </p:sp>
-      <p:sp>
-        <p:nvSpPr>
-          <p:cNvPr id="111" name="Bracket dataset"/>
-          <p:cNvSpPr/>
-          <p:nvPr/>
-        </p:nvSpPr>
-        <p:spPr>
-          <a:xfrm>
-            <a:off x="6227064" y="3639312"/>
-            <a:ext cx="3456432" cy="128016"/>
-          </a:xfrm>
-          <a:prstGeom prst="rect">
-            <a:avLst/>
-          </a:prstGeom>
-          <a:noFill/>
-          <a:ln w="19050">
-            <a:solidFill>
-              <a:srgbClr val="2E6B57"/>
-            </a:solidFill>
-            <a:prstDash val="dash"/>
-          </a:ln>
-        </p:spPr>
-      </p:sp>
-      <p:sp>
-        <p:nvSpPr>
-          <p:cNvPr id="112" name="Bracket label"/>
-          <p:cNvSpPr/>
-          <p:nvPr/>
-        </p:nvSpPr>
-        <p:spPr>
-          <a:xfrm>
-            <a:off x="6135624" y="3840480"/>
-            <a:ext cx="3639312" cy="777240"/>
-          </a:xfrm>
-          <a:prstGeom prst="rect">
-            <a:avLst/>
-          </a:prstGeom>
-          <a:noFill/>
-          <a:ln>
-            <a:noFill/>
-          </a:ln>
-        </p:spPr>
-        <p:txBody>
-          <a:bodyPr wrap="square" lIns="18288" rIns="18288" tIns="18288" bIns="18288" rtlCol="0" anchor="t">
-            <a:noAutofit/>
-          </a:bodyPr>
-          <a:lstStyle/>
-          <a:p>
-            <a:pPr algn="ctr" indent="0" marL="0">
-              <a:lnSpc>
-                <a:spcPct val="115000"/>
-              </a:lnSpc>
-              <a:spcAft>
-                <a:spcPts val="0"/>
-              </a:spcAft>
-              <a:buNone/>
-            </a:pPr>
-            <a:r>
-              <a:rPr lang="pt-BR" sz="1100" b="1" i="0" dirty="0">
-                <a:solidFill>
-                  <a:srgbClr val="2E6B57"/>
-                </a:solidFill>
-                <a:latin typeface="Poppins"/>
-                <a:ea typeface="Poppins"/>
-                <a:cs typeface="Poppins"/>
-              </a:rPr>
-              <a:t>Nesta entrega, explicação e patch vêm do dataset; nenhum LLM está rodando. </a:t>
-            </a:r>
-            <a:r>
-              <a:rPr lang="pt-BR" sz="1100" b="0" i="0" dirty="0">
-                <a:solidFill>
-                  <a:srgbClr val="000000"/>
-                </a:solidFill>
-                <a:latin typeface="Poppins"/>
-                <a:ea typeface="Poppins"/>
-                <a:cs typeface="Poppins"/>
-              </a:rPr>
-              <a:t>O modelo local (via Ollama) é planejado para a próxima etapa.</a:t>
-            </a:r>
-          </a:p>
-        </p:txBody>
-      </p:sp>
-      <p:sp>
-        <p:nvSpPr>
-          <p:cNvPr id="113" name="Step label 1"/>
-          <p:cNvSpPr/>
-          <p:nvPr/>
-        </p:nvSpPr>
-        <p:spPr>
-          <a:xfrm>
-            <a:off x="2441448" y="3639312"/>
-            <a:ext cx="1563624" cy="365760"/>
-          </a:xfrm>
-          <a:prstGeom prst="rect">
-            <a:avLst/>
-          </a:prstGeom>
-          <a:noFill/>
-          <a:ln>
-            <a:noFill/>
-          </a:ln>
-        </p:spPr>
-        <p:txBody>
-          <a:bodyPr wrap="square" lIns="18288" rIns="18288" tIns="18288" bIns="18288" rtlCol="0" anchor="t">
-            <a:noAutofit/>
-          </a:bodyPr>
-          <a:lstStyle/>
-          <a:p>
-            <a:pPr algn="ctr" indent="0" marL="0">
-              <a:lnSpc>
-                <a:spcPct val="115000"/>
-              </a:lnSpc>
-              <a:spcAft>
-                <a:spcPts val="0"/>
-              </a:spcAft>
-              <a:buNone/>
-            </a:pPr>
-            <a:r>
-              <a:rPr lang="pt-BR" sz="1100" b="0" i="0" dirty="0">
-                <a:solidFill>
-                  <a:srgbClr val="787878"/>
-                </a:solidFill>
-                <a:latin typeface="Lexend"/>
-                <a:ea typeface="Lexend"/>
-                <a:cs typeface="Lexend"/>
-              </a:rPr>
-              <a:t>1 · detecta</a:t>
-            </a:r>
-          </a:p>
-        </p:txBody>
-      </p:sp>
-      <p:sp>
-        <p:nvSpPr>
-          <p:cNvPr id="114" name="Step label 5"/>
-          <p:cNvSpPr/>
-          <p:nvPr/>
-        </p:nvSpPr>
-        <p:spPr>
-          <a:xfrm>
-            <a:off x="10012680" y="3639312"/>
-            <a:ext cx="1563624" cy="365760"/>
-          </a:xfrm>
-          <a:prstGeom prst="rect">
-            <a:avLst/>
-          </a:prstGeom>
-          <a:noFill/>
-          <a:ln>
-            <a:noFill/>
-          </a:ln>
-        </p:spPr>
-        <p:txBody>
-          <a:bodyPr wrap="square" lIns="18288" rIns="18288" tIns="18288" bIns="18288" rtlCol="0" anchor="t">
-            <a:noAutofit/>
-          </a:bodyPr>
-          <a:lstStyle/>
-          <a:p>
-            <a:pPr algn="ctr" indent="0" marL="0">
-              <a:lnSpc>
-                <a:spcPct val="115000"/>
-              </a:lnSpc>
-              <a:spcAft>
-                <a:spcPts val="0"/>
-              </a:spcAft>
-              <a:buNone/>
-            </a:pPr>
-            <a:r>
-              <a:rPr lang="pt-BR" sz="1100" b="0" i="0" dirty="0">
-                <a:solidFill>
-                  <a:srgbClr val="787878"/>
-                </a:solidFill>
-                <a:latin typeface="Lexend"/>
-                <a:ea typeface="Lexend"/>
-                <a:cs typeface="Lexend"/>
-              </a:rPr>
-              <a:t>3 · confere</a:t>
-            </a:r>
-          </a:p>
-        </p:txBody>
-      </p:sp>
-      <p:sp>
-        <p:nvSpPr>
-          <p:cNvPr id="115" name="Resp heading"/>
-          <p:cNvSpPr/>
-          <p:nvPr/>
-        </p:nvSpPr>
-        <p:spPr>
-          <a:xfrm>
-            <a:off x="548640" y="4983480"/>
-            <a:ext cx="5394960" cy="365760"/>
-          </a:xfrm>
-          <a:prstGeom prst="rect">
-            <a:avLst/>
-          </a:prstGeom>
-          <a:noFill/>
-          <a:ln>
-            <a:noFill/>
-          </a:ln>
-        </p:spPr>
-        <p:txBody>
-          <a:bodyPr wrap="square" lIns="0" rIns="0" tIns="0" bIns="0" rtlCol="0" anchor="t">
-            <a:noAutofit/>
-          </a:bodyPr>
-          <a:lstStyle/>
-          <a:p>
-            <a:pPr algn="l" indent="0" marL="0">
-              <a:lnSpc>
-                <a:spcPct val="115000"/>
-              </a:lnSpc>
-              <a:spcAft>
-                <a:spcPts val="0"/>
-              </a:spcAft>
-              <a:buNone/>
-            </a:pPr>
-            <a:r>
-              <a:rPr lang="pt-BR" sz="1600" b="0" i="0" dirty="0">
-                <a:solidFill>
-                  <a:srgbClr val="000000"/>
-                </a:solidFill>
-                <a:latin typeface="Lexend"/>
-                <a:ea typeface="Lexend"/>
-                <a:cs typeface="Lexend"/>
-              </a:rPr>
-              <a:t>Divisão de responsabilidades</a:t>
-            </a:r>
-          </a:p>
-        </p:txBody>
-      </p:sp>
-      <p:sp>
-        <p:nvSpPr>
-          <p:cNvPr id="116" name="Resp body"/>
-          <p:cNvSpPr/>
-          <p:nvPr/>
-        </p:nvSpPr>
-        <p:spPr>
-          <a:xfrm>
-            <a:off x="548640" y="5394960"/>
-            <a:ext cx="5394960" cy="1005840"/>
-          </a:xfrm>
-          <a:prstGeom prst="rect">
-            <a:avLst/>
-          </a:prstGeom>
-          <a:noFill/>
-          <a:ln>
-            <a:noFill/>
-          </a:ln>
-        </p:spPr>
-        <p:txBody>
-          <a:bodyPr wrap="square" lIns="0" rIns="0" tIns="0" bIns="0" rtlCol="0" anchor="t">
-            <a:noAutofit/>
-          </a:bodyPr>
-          <a:lstStyle/>
-          <a:p>
-            <a:pPr algn="l" indent="0" marL="0">
-              <a:lnSpc>
-                <a:spcPct val="115000"/>
-              </a:lnSpc>
-              <a:spcAft>
-                <a:spcPts val="0"/>
-              </a:spcAft>
-              <a:buNone/>
-            </a:pPr>
-            <a:r>
-              <a:rPr lang="pt-BR" sz="1200" b="0" i="0" dirty="0">
-                <a:solidFill>
-                  <a:srgbClr val="000000"/>
-                </a:solidFill>
-                <a:latin typeface="Poppins"/>
-                <a:ea typeface="Poppins"/>
-                <a:cs typeface="Poppins"/>
-              </a:rPr>
-              <a:t>O LLM entra onde é bom: linguagem e reescrita de código. A decisão sobre o que é vulnerável fica com a ferramenta auditável.</a:t>
-            </a:r>
-          </a:p>
-        </p:txBody>
-      </p:sp>
-      <p:sp>
-        <p:nvSpPr>
-          <p:cNvPr id="117" name="Legend swatch 0"/>
-          <p:cNvSpPr/>
-          <p:nvPr/>
-        </p:nvSpPr>
-        <p:spPr>
-          <a:xfrm>
-            <a:off x="6492240" y="5093208"/>
-            <a:ext cx="237744" cy="237744"/>
-          </a:xfrm>
-          <a:prstGeom prst="rect">
-            <a:avLst/>
-          </a:prstGeom>
-          <a:solidFill>
-            <a:srgbClr val="1F2A27"/>
-          </a:solidFill>
-          <a:ln>
-            <a:noFill/>
-          </a:ln>
-        </p:spPr>
-      </p:sp>
-      <p:sp>
-        <p:nvSpPr>
-          <p:cNvPr id="118" name="Legend text 0"/>
-          <p:cNvSpPr/>
-          <p:nvPr/>
-        </p:nvSpPr>
-        <p:spPr>
-          <a:xfrm>
-            <a:off x="6858000" y="5029200"/>
-            <a:ext cx="4754880" cy="365760"/>
-          </a:xfrm>
-          <a:prstGeom prst="rect">
-            <a:avLst/>
-          </a:prstGeom>
-          <a:noFill/>
-          <a:ln>
-            <a:noFill/>
-          </a:ln>
-        </p:spPr>
-        <p:txBody>
-          <a:bodyPr wrap="square" lIns="18288" rIns="18288" tIns="18288" bIns="18288" rtlCol="0" anchor="ctr">
-            <a:noAutofit/>
-          </a:bodyPr>
-          <a:lstStyle/>
-          <a:p>
-            <a:pPr algn="l" indent="0" marL="0">
-              <a:lnSpc>
-                <a:spcPct val="115000"/>
-              </a:lnSpc>
-              <a:spcAft>
-                <a:spcPts val="0"/>
-              </a:spcAft>
-              <a:buNone/>
-            </a:pPr>
-            <a:r>
-              <a:rPr lang="pt-BR" sz="1200" b="0" i="0" dirty="0">
-                <a:solidFill>
-                  <a:srgbClr val="000000"/>
-                </a:solidFill>
-                <a:latin typeface="Poppins"/>
-                <a:ea typeface="Poppins"/>
-                <a:cs typeface="Poppins"/>
-              </a:rPr>
-              <a:t>Opengrep: determinístico e auditável; decide o que é vulnerável</a:t>
-            </a:r>
-          </a:p>
-        </p:txBody>
-      </p:sp>
-      <p:sp>
-        <p:nvSpPr>
-          <p:cNvPr id="119" name="Legend swatch 1"/>
-          <p:cNvSpPr/>
-          <p:nvPr/>
-        </p:nvSpPr>
-        <p:spPr>
-          <a:xfrm>
-            <a:off x="6492240" y="5504688"/>
-            <a:ext cx="237744" cy="237744"/>
-          </a:xfrm>
-          <a:prstGeom prst="rect">
-            <a:avLst/>
-          </a:prstGeom>
-          <a:solidFill>
-            <a:srgbClr val="2E6B57"/>
-          </a:solidFill>
-          <a:ln>
-            <a:noFill/>
-          </a:ln>
-        </p:spPr>
-      </p:sp>
-      <p:sp>
-        <p:nvSpPr>
-          <p:cNvPr id="120" name="Legend text 1"/>
-          <p:cNvSpPr/>
-          <p:nvPr/>
-        </p:nvSpPr>
-        <p:spPr>
-          <a:xfrm>
-            <a:off x="6858000" y="5440680"/>
-            <a:ext cx="4754880" cy="365760"/>
-          </a:xfrm>
-          <a:prstGeom prst="rect">
-            <a:avLst/>
-          </a:prstGeom>
-          <a:noFill/>
-          <a:ln>
-            <a:noFill/>
-          </a:ln>
-        </p:spPr>
-        <p:txBody>
-          <a:bodyPr wrap="square" lIns="18288" rIns="18288" tIns="18288" bIns="18288" rtlCol="0" anchor="ctr">
-            <a:noAutofit/>
-          </a:bodyPr>
-          <a:lstStyle/>
-          <a:p>
-            <a:pPr algn="l" indent="0" marL="0">
-              <a:lnSpc>
-                <a:spcPct val="115000"/>
-              </a:lnSpc>
-              <a:spcAft>
-                <a:spcPts val="0"/>
-              </a:spcAft>
-              <a:buNone/>
-            </a:pPr>
-            <a:r>
-              <a:rPr lang="pt-BR" sz="1200" b="0" i="0" dirty="0">
-                <a:solidFill>
-                  <a:srgbClr val="000000"/>
-                </a:solidFill>
-                <a:latin typeface="Poppins"/>
-                <a:ea typeface="Poppins"/>
-                <a:cs typeface="Poppins"/>
-              </a:rPr>
-              <a:t>LLM local: explica e propõe o patch (próxima etapa)</a:t>
-            </a:r>
-          </a:p>
-        </p:txBody>
-      </p:sp>
-      <p:sp>
-        <p:nvSpPr>
-          <p:cNvPr id="121" name="Legend swatch 2"/>
-          <p:cNvSpPr/>
-          <p:nvPr/>
-        </p:nvSpPr>
-        <p:spPr>
-          <a:xfrm>
-            <a:off x="6492240" y="5916168"/>
-            <a:ext cx="237744" cy="237744"/>
-          </a:xfrm>
-          <a:prstGeom prst="rect">
-            <a:avLst/>
-          </a:prstGeom>
-          <a:solidFill>
-            <a:srgbClr val="CCCCCC"/>
-          </a:solidFill>
-          <a:ln>
-            <a:noFill/>
-          </a:ln>
-        </p:spPr>
-      </p:sp>
-      <p:sp>
-        <p:nvSpPr>
-          <p:cNvPr id="122" name="Legend text 2"/>
-          <p:cNvSpPr/>
-          <p:nvPr/>
-        </p:nvSpPr>
-        <p:spPr>
-          <a:xfrm>
-            <a:off x="6858000" y="5852160"/>
-            <a:ext cx="4754880" cy="365760"/>
-          </a:xfrm>
-          <a:prstGeom prst="rect">
-            <a:avLst/>
-          </a:prstGeom>
-          <a:noFill/>
-          <a:ln>
-            <a:noFill/>
-          </a:ln>
-        </p:spPr>
-        <p:txBody>
-          <a:bodyPr wrap="square" lIns="18288" rIns="18288" tIns="18288" bIns="18288" rtlCol="0" anchor="ctr">
-            <a:noAutofit/>
-          </a:bodyPr>
-          <a:lstStyle/>
-          <a:p>
-            <a:pPr algn="l" indent="0" marL="0">
-              <a:lnSpc>
-                <a:spcPct val="115000"/>
-              </a:lnSpc>
-              <a:spcAft>
-                <a:spcPts val="0"/>
-              </a:spcAft>
-              <a:buNone/>
-            </a:pPr>
-            <a:r>
-              <a:rPr lang="pt-BR" sz="1200" b="0" i="0" dirty="0">
-                <a:solidFill>
-                  <a:srgbClr val="000000"/>
-                </a:solidFill>
-                <a:latin typeface="Poppins"/>
-                <a:ea typeface="Poppins"/>
-                <a:cs typeface="Poppins"/>
-              </a:rPr>
-              <a:t>Dados trocados entre as etapas</a:t>
-            </a:r>
-          </a:p>
-        </p:txBody>
-      </p:sp>
+      <p:pic>
+        <p:nvPicPr>
+          <p:cNvPr id="200" name="Arquitetura Cylab v0.4" descr="Arquitetura do Cylab: pipeline híbrido 100% local. Opengrep detecta (regra, CWE, trecho); LLM local via Ollama (planejado) explica em pt-BR e propõe o patch; re-scan Opengrep confere (aceite se achados(before) ≥ 1 e achados(after) = 0). Faixa do dataset ouro v0.4-gold: 2.191 v0.2 comercial → 476 v0.3-gold → +100 buffer de realismo → 576 v0.4-gold, gate 576/576; 489 treino, 87 holdout."/>
+          <p:cNvPicPr>
+            <a:picLocks noChangeAspect="1"/>
+          </p:cNvPicPr>
+          <p:nvPr/>
+        </p:nvPicPr>
+        <p:blipFill>
+          <a:blip r:embed="rIdArq"/>
+          <a:stretch>
+            <a:fillRect/>
+          </a:stretch>
+        </p:blipFill>
+        <p:spPr>
+          <a:xfrm>
+            <a:off x="1692446" y="1371600"/>
+            <a:ext cx="8806802" cy="5074920"/>
+          </a:xfrm>
+          <a:prstGeom prst="rect">
+            <a:avLst/>
+          </a:prstGeom>
+        </p:spPr>
+      </p:pic>
     </p:spTree>
   </p:cSld>
   <p:clrMapOvr>
@@ -4674,7 +3739,7 @@
                 <a:ea typeface="Poppins" pitchFamily="34" charset="-122"/>
                 <a:cs typeface="Poppins" pitchFamily="34" charset="-120"/>
               </a:rPr>
-              <a:t>8</a:t>
+              <a:t>9</a:t>
             </a:r>
             <a:endParaRPr lang="en-US" sz="1200" dirty="0"/>
           </a:p>
@@ -4724,7 +3789,7 @@
                 <a:ea typeface="Lexend" pitchFamily="34" charset="-122"/>
                 <a:cs typeface="Lexend" pitchFamily="34" charset="-120"/>
               </a:rPr>
-              <a:t>v0.3-gold</a:t>
+              <a:t>v0.4-gold</a:t>
             </a:r>
             <a:endParaRPr lang="en-US" sz="4400" dirty="0"/>
           </a:p>
@@ -4786,7 +3851,7 @@
                 <a:ea typeface="Poppins" pitchFamily="34" charset="-122"/>
                 <a:cs typeface="Poppins" pitchFamily="34" charset="-120"/>
               </a:rPr>
-              <a:t>401 pares de treino e 75 de holdout. A deduplicação foi feita antes da partição.</a:t>
+              <a:t>489 pares de treino e 87 de holdout. A deduplicação foi feita antes da partição.</a:t>
             </a:r>
             <a:endParaRPr lang="en-US" sz="1200" dirty="0"/>
           </a:p>
@@ -4825,7 +3890,7 @@
                 <a:ea typeface="Lexend" pitchFamily="34" charset="-122"/>
                 <a:cs typeface="Lexend" pitchFamily="34" charset="-120"/>
               </a:rPr>
-              <a:t>Partição 401 / 75</a:t>
+              <a:t>Partição 489 / 87</a:t>
             </a:r>
             <a:endParaRPr lang="en-US" sz="1400" dirty="0"/>
           </a:p>
@@ -5038,227 +4103,6 @@
               <a:t>C/C++/Bash 182 · complemento +51</a:t>
             </a:r>
           </a:p>
-        </p:txBody>
-      </p:sp>
-      <p:sp>
-        <p:nvSpPr>
-          <p:cNvPr id="14" name="Text 12"/>
-          <p:cNvSpPr/>
-          <p:nvPr/>
-        </p:nvSpPr>
-        <p:spPr>
-          <a:xfrm>
-            <a:off x="7178040" y="4937760"/>
-            <a:ext cx="3063240" cy="411480"/>
-          </a:xfrm>
-          <a:prstGeom prst="rect">
-            <a:avLst/>
-          </a:prstGeom>
-          <a:noFill/>
-          <a:ln/>
-        </p:spPr>
-        <p:txBody>
-          <a:bodyPr wrap="square" rtlCol="0" anchor="t"/>
-          <a:lstStyle/>
-          <a:p>
-            <a:pPr algn="l" indent="0" marL="0">
-              <a:buNone/>
-            </a:pPr>
-            <a:r>
-              <a:rPr lang="en-US" sz="1800" dirty="0">
-                <a:solidFill>
-                  <a:srgbClr val="000000"/>
-                </a:solidFill>
-                <a:latin typeface="Lexend" pitchFamily="34" charset="0"/>
-                <a:ea typeface="Lexend" pitchFamily="34" charset="-122"/>
-                <a:cs typeface="Lexend" pitchFamily="34" charset="-120"/>
-              </a:rPr>
-              <a:t>Procedência</a:t>
-            </a:r>
-            <a:endParaRPr lang="en-US" sz="1400" dirty="0"/>
-          </a:p>
-        </p:txBody>
-      </p:sp>
-      <p:sp>
-        <p:nvSpPr>
-          <p:cNvPr id="15" name="Text 13"/>
-          <p:cNvSpPr/>
-          <p:nvPr/>
-        </p:nvSpPr>
-        <p:spPr>
-          <a:xfrm>
-            <a:off x="702259" y="2331720"/>
-            <a:ext cx="2103120" cy="1097280"/>
-          </a:xfrm>
-          <a:prstGeom prst="rect">
-            <a:avLst/>
-          </a:prstGeom>
-          <a:noFill/>
-          <a:ln/>
-        </p:spPr>
-        <p:txBody>
-          <a:bodyPr wrap="square" rtlCol="0" anchor="t"/>
-          <a:lstStyle/>
-          <a:p>
-            <a:pPr algn="l" indent="0" marL="0">
-              <a:buNone/>
-            </a:pPr>
-            <a:r>
-              <a:rPr lang="en-US" sz="7200" dirty="0">
-                <a:solidFill>
-                  <a:srgbClr val="000000"/>
-                </a:solidFill>
-                <a:latin typeface="Lexend" pitchFamily="34" charset="0"/>
-                <a:ea typeface="Lexend" pitchFamily="34" charset="-122"/>
-                <a:cs typeface="Lexend" pitchFamily="34" charset="-120"/>
-              </a:rPr>
-              <a:t>476</a:t>
-            </a:r>
-            <a:endParaRPr lang="en-US" sz="4800" dirty="0"/>
-          </a:p>
-        </p:txBody>
-      </p:sp>
-      <p:sp>
-        <p:nvSpPr>
-          <p:cNvPr id="16" name="Text 14"/>
-          <p:cNvSpPr/>
-          <p:nvPr/>
-        </p:nvSpPr>
-        <p:spPr>
-          <a:xfrm>
-            <a:off x="2788920" y="2697480"/>
-            <a:ext cx="3291840" cy="411480"/>
-          </a:xfrm>
-          <a:prstGeom prst="rect">
-            <a:avLst/>
-          </a:prstGeom>
-          <a:noFill/>
-          <a:ln/>
-        </p:spPr>
-        <p:txBody>
-          <a:bodyPr wrap="square" rtlCol="0" anchor="t"/>
-          <a:lstStyle/>
-          <a:p>
-            <a:pPr algn="ctr" indent="0" marL="0">
-              <a:lnSpc>
-                <a:spcPct val="130000"/>
-              </a:lnSpc>
-              <a:buNone/>
-            </a:pPr>
-            <a:r>
-              <a:rPr lang="en-US" sz="1400" dirty="0">
-                <a:solidFill>
-                  <a:srgbClr val="000000"/>
-                </a:solidFill>
-                <a:latin typeface="Poppins" pitchFamily="34" charset="0"/>
-                <a:ea typeface="Poppins" pitchFamily="34" charset="-122"/>
-                <a:cs typeface="Poppins" pitchFamily="34" charset="-120"/>
-              </a:rPr>
-              <a:t>pares · gate 476/476</a:t>
-            </a:r>
-            <a:endParaRPr lang="en-US" sz="1200" dirty="0"/>
-          </a:p>
-        </p:txBody>
-      </p:sp>
-      <p:sp>
-        <p:nvSpPr>
-          <p:cNvPr id="17" name="Text 15"/>
-          <p:cNvSpPr/>
-          <p:nvPr/>
-        </p:nvSpPr>
-        <p:spPr>
-          <a:xfrm>
-            <a:off x="702259" y="3611880"/>
-            <a:ext cx="5669280" cy="1188720"/>
-          </a:xfrm>
-          <a:prstGeom prst="rect">
-            <a:avLst/>
-          </a:prstGeom>
-          <a:noFill/>
-          <a:ln/>
-        </p:spPr>
-        <p:txBody>
-          <a:bodyPr wrap="square" rtlCol="0" anchor="t"/>
-          <a:lstStyle/>
-          <a:p>
-            <a:pPr algn="l" indent="0" marL="0">
-              <a:lnSpc>
-                <a:spcPct val="130000"/>
-              </a:lnSpc>
-              <a:buNone/>
-            </a:pPr>
-            <a:r>
-              <a:rPr lang="en-US" sz="1300" dirty="0">
-                <a:solidFill>
-                  <a:srgbClr val="2E6B57"/>
-                </a:solidFill>
-                <a:latin typeface="Poppins" pitchFamily="34" charset="0"/>
-                <a:ea typeface="Poppins" pitchFamily="34" charset="-122"/>
-                <a:cs typeface="Poppins" pitchFamily="34" charset="-120"/>
-              </a:rPr>
-              <a:t>Por linguagem: </a:t>
-            </a:r>
-            <a:r>
-              <a:rPr lang="en-US" sz="1300" dirty="0">
-                <a:solidFill>
-                  <a:srgbClr val="000000"/>
-                </a:solidFill>
-                <a:latin typeface="Poppins" pitchFamily="34" charset="0"/>
-                <a:ea typeface="Poppins" pitchFamily="34" charset="-122"/>
-                <a:cs typeface="Poppins" pitchFamily="34" charset="-120"/>
-              </a:rPr>
-              <a:t>C++ 74 · Python 68 · JavaScript 63 · C 55 · Bash 55 · Java 34 · SQL 34 · TypeScript 33 · PHP 33 · C# 27</a:t>
-            </a:r>
-            <a:endParaRPr lang="en-US" sz="1200" dirty="0"/>
-          </a:p>
-        </p:txBody>
-      </p:sp>
-      <p:sp>
-        <p:nvSpPr>
-          <p:cNvPr id="18" name="Shape 16"/>
-          <p:cNvSpPr/>
-          <p:nvPr/>
-        </p:nvSpPr>
-        <p:spPr>
-          <a:xfrm>
-            <a:off x="777240" y="1828800"/>
-            <a:ext cx="1273759" cy="102413"/>
-          </a:xfrm>
-          <a:prstGeom prst="roundRect">
-            <a:avLst>
-              <a:gd name="adj" fmla="val 50000"/>
-            </a:avLst>
-          </a:prstGeom>
-          <a:solidFill>
-            <a:srgbClr val="2E6B57"/>
-          </a:solidFill>
-          <a:ln/>
-        </p:spPr>
-      </p:sp>
-      <p:sp>
-        <p:nvSpPr>
-          <p:cNvPr id="301" name="Commercial note"/>
-          <p:cNvSpPr/>
-          <p:nvPr/>
-        </p:nvSpPr>
-        <p:spPr>
-          <a:xfrm>
-            <a:off x="702259" y="4892040"/>
-            <a:ext cx="5669280" cy="1188720"/>
-          </a:xfrm>
-          <a:prstGeom prst="rect">
-            <a:avLst/>
-          </a:prstGeom>
-          <a:noFill/>
-          <a:ln>
-            <a:noFill/>
-          </a:ln>
-        </p:spPr>
-        <p:txBody>
-          <a:bodyPr wrap="square" lIns="0" rIns="0" tIns="0" bIns="0" rtlCol="0" anchor="t">
-            <a:noAutofit/>
-          </a:bodyPr>
-          <a:lstStyle/>
           <a:p>
             <a:pPr algn="l" indent="0" marL="0">
               <a:lnSpc>
@@ -5270,26 +4114,298 @@
               <a:buNone/>
             </a:pPr>
             <a:r>
-              <a:rPr lang="pt-BR" sz="1200" b="1" i="0" dirty="0">
-                <a:solidFill>
-                  <a:srgbClr val="2E6B57"/>
+              <a:rPr lang="pt-BR" sz="1200" b="0" i="0" dirty="0">
+                <a:solidFill>
+                  <a:srgbClr val="000000"/>
                 </a:solidFill>
                 <a:latin typeface="Poppins"/>
                 <a:ea typeface="Poppins"/>
                 <a:cs typeface="Poppins"/>
               </a:rPr>
-              <a:t>Sobre o nome do arquivo: </a:t>
-            </a:r>
-            <a:r>
-              <a:rPr lang="pt-BR" sz="1200" b="0" i="0" dirty="0">
-                <a:solidFill>
-                  <a:srgbClr val="000000"/>
+              <a:t>realismo v0.4 +100</a:t>
+            </a:r>
+          </a:p>
+        </p:txBody>
+      </p:sp>
+      <p:sp>
+        <p:nvSpPr>
+          <p:cNvPr id="14" name="Text 12"/>
+          <p:cNvSpPr/>
+          <p:nvPr/>
+        </p:nvSpPr>
+        <p:spPr>
+          <a:xfrm>
+            <a:off x="7178040" y="4937760"/>
+            <a:ext cx="3063240" cy="411480"/>
+          </a:xfrm>
+          <a:prstGeom prst="rect">
+            <a:avLst/>
+          </a:prstGeom>
+          <a:noFill/>
+          <a:ln/>
+        </p:spPr>
+        <p:txBody>
+          <a:bodyPr wrap="square" rtlCol="0" anchor="t"/>
+          <a:lstStyle/>
+          <a:p>
+            <a:pPr algn="l" indent="0" marL="0">
+              <a:buNone/>
+            </a:pPr>
+            <a:r>
+              <a:rPr lang="en-US" sz="1800" dirty="0">
+                <a:solidFill>
+                  <a:srgbClr val="000000"/>
+                </a:solidFill>
+                <a:latin typeface="Lexend" pitchFamily="34" charset="0"/>
+                <a:ea typeface="Lexend" pitchFamily="34" charset="-122"/>
+                <a:cs typeface="Lexend" pitchFamily="34" charset="-120"/>
+              </a:rPr>
+              <a:t>Procedência</a:t>
+            </a:r>
+            <a:endParaRPr lang="en-US" sz="1400" dirty="0"/>
+          </a:p>
+        </p:txBody>
+      </p:sp>
+      <p:sp>
+        <p:nvSpPr>
+          <p:cNvPr id="15" name="Text 13"/>
+          <p:cNvSpPr/>
+          <p:nvPr/>
+        </p:nvSpPr>
+        <p:spPr>
+          <a:xfrm>
+            <a:off x="702259" y="2331720"/>
+            <a:ext cx="2103120" cy="1097280"/>
+          </a:xfrm>
+          <a:prstGeom prst="rect">
+            <a:avLst/>
+          </a:prstGeom>
+          <a:noFill/>
+          <a:ln/>
+        </p:spPr>
+        <p:txBody>
+          <a:bodyPr wrap="square" rtlCol="0" anchor="t"/>
+          <a:lstStyle/>
+          <a:p>
+            <a:pPr algn="l" indent="0" marL="0">
+              <a:buNone/>
+            </a:pPr>
+            <a:r>
+              <a:rPr lang="en-US" sz="7200" dirty="0">
+                <a:solidFill>
+                  <a:srgbClr val="000000"/>
+                </a:solidFill>
+                <a:latin typeface="Lexend" pitchFamily="34" charset="0"/>
+                <a:ea typeface="Lexend" pitchFamily="34" charset="-122"/>
+                <a:cs typeface="Lexend" pitchFamily="34" charset="-120"/>
+              </a:rPr>
+              <a:t>576</a:t>
+            </a:r>
+            <a:endParaRPr lang="en-US" sz="4800" dirty="0"/>
+          </a:p>
+        </p:txBody>
+      </p:sp>
+      <p:sp>
+        <p:nvSpPr>
+          <p:cNvPr id="16" name="Text 14"/>
+          <p:cNvSpPr/>
+          <p:nvPr/>
+        </p:nvSpPr>
+        <p:spPr>
+          <a:xfrm>
+            <a:off x="2788920" y="2697480"/>
+            <a:ext cx="3291840" cy="411480"/>
+          </a:xfrm>
+          <a:prstGeom prst="rect">
+            <a:avLst/>
+          </a:prstGeom>
+          <a:noFill/>
+          <a:ln/>
+        </p:spPr>
+        <p:txBody>
+          <a:bodyPr wrap="square" rtlCol="0" anchor="t"/>
+          <a:lstStyle/>
+          <a:p>
+            <a:pPr algn="ctr" indent="0" marL="0">
+              <a:lnSpc>
+                <a:spcPct val="130000"/>
+              </a:lnSpc>
+              <a:buNone/>
+            </a:pPr>
+            <a:r>
+              <a:rPr lang="en-US" sz="1400" dirty="0">
+                <a:solidFill>
+                  <a:srgbClr val="000000"/>
+                </a:solidFill>
+                <a:latin typeface="Poppins" pitchFamily="34" charset="0"/>
+                <a:ea typeface="Poppins" pitchFamily="34" charset="-122"/>
+                <a:cs typeface="Poppins" pitchFamily="34" charset="-120"/>
+              </a:rPr>
+              <a:t>pares · gate 576/576</a:t>
+            </a:r>
+            <a:endParaRPr lang="en-US" sz="1200" dirty="0"/>
+          </a:p>
+        </p:txBody>
+      </p:sp>
+      <p:sp>
+        <p:nvSpPr>
+          <p:cNvPr id="17" name="Text 15"/>
+          <p:cNvSpPr/>
+          <p:nvPr/>
+        </p:nvSpPr>
+        <p:spPr>
+          <a:xfrm>
+            <a:off x="702259" y="3611880"/>
+            <a:ext cx="5669280" cy="1188720"/>
+          </a:xfrm>
+          <a:prstGeom prst="rect">
+            <a:avLst/>
+          </a:prstGeom>
+          <a:noFill/>
+          <a:ln/>
+        </p:spPr>
+        <p:txBody>
+          <a:bodyPr wrap="square" rtlCol="0" anchor="t"/>
+          <a:lstStyle/>
+          <a:p>
+            <a:pPr algn="l" indent="0" marL="0">
+              <a:lnSpc>
+                <a:spcPct val="130000"/>
+              </a:lnSpc>
+              <a:buNone/>
+            </a:pPr>
+            <a:r>
+              <a:rPr lang="en-US" sz="1300" dirty="0">
+                <a:solidFill>
+                  <a:srgbClr val="2E6B57"/>
+                </a:solidFill>
+                <a:latin typeface="Poppins" pitchFamily="34" charset="0"/>
+                <a:ea typeface="Poppins" pitchFamily="34" charset="-122"/>
+                <a:cs typeface="Poppins" pitchFamily="34" charset="-120"/>
+              </a:rPr>
+              <a:t>Por linguagem: </a:t>
+            </a:r>
+            <a:r>
+              <a:rPr lang="en-US" sz="1300" dirty="0">
+                <a:solidFill>
+                  <a:srgbClr val="000000"/>
+                </a:solidFill>
+                <a:latin typeface="Poppins" pitchFamily="34" charset="0"/>
+                <a:ea typeface="Poppins" pitchFamily="34" charset="-122"/>
+                <a:cs typeface="Poppins" pitchFamily="34" charset="-120"/>
+              </a:rPr>
+              <a:t>C++ 86 · Python 74 · JavaScript 68 · C 67 · Bash 67 · SQL 65 · Java 40 · PHP 39 · TypeScript 37 · C# 33</a:t>
+            </a:r>
+            <a:endParaRPr lang="en-US" sz="1200" dirty="0"/>
+          </a:p>
+        </p:txBody>
+      </p:sp>
+      <p:sp>
+        <p:nvSpPr>
+          <p:cNvPr id="18" name="Shape 16"/>
+          <p:cNvSpPr/>
+          <p:nvPr/>
+        </p:nvSpPr>
+        <p:spPr>
+          <a:xfrm>
+            <a:off x="777240" y="1828800"/>
+            <a:ext cx="1273759" cy="102413"/>
+          </a:xfrm>
+          <a:prstGeom prst="roundRect">
+            <a:avLst>
+              <a:gd name="adj" fmla="val 50000"/>
+            </a:avLst>
+          </a:prstGeom>
+          <a:solidFill>
+            <a:srgbClr val="2E6B57"/>
+          </a:solidFill>
+          <a:ln/>
+        </p:spPr>
+      </p:sp>
+      <p:sp>
+        <p:nvSpPr>
+          <p:cNvPr id="301" name="Commercial note"/>
+          <p:cNvSpPr/>
+          <p:nvPr/>
+        </p:nvSpPr>
+        <p:spPr>
+          <a:xfrm>
+            <a:off x="702259" y="4892040"/>
+            <a:ext cx="5669280" cy="1188720"/>
+          </a:xfrm>
+          <a:prstGeom prst="rect">
+            <a:avLst/>
+          </a:prstGeom>
+          <a:noFill/>
+          <a:ln>
+            <a:noFill/>
+          </a:ln>
+        </p:spPr>
+        <p:txBody>
+          <a:bodyPr wrap="square" lIns="0" rIns="0" tIns="0" bIns="0" rtlCol="0" anchor="t">
+            <a:noAutofit/>
+          </a:bodyPr>
+          <a:lstStyle/>
+          <a:p>
+            <a:pPr algn="l" indent="0" marL="0">
+              <a:lnSpc>
+                <a:spcPct val="115000"/>
+              </a:lnSpc>
+              <a:spcAft>
+                <a:spcPts val="0"/>
+              </a:spcAft>
+              <a:buNone/>
+            </a:pPr>
+            <a:r>
+              <a:rPr lang="pt-BR" sz="1200" b="1" i="0" dirty="0">
+                <a:solidFill>
+                  <a:srgbClr val="2E6B57"/>
                 </a:solidFill>
                 <a:latin typeface="Poppins"/>
                 <a:ea typeface="Poppins"/>
                 <a:cs typeface="Poppins"/>
               </a:rPr>
-              <a:t>data/cylab-commercial-v0.3-gold.jsonl. “commercial” vem da linha de escala (meta de ~2 mil pares na v0.2) e não restringe o uso: a licença é CC-BY-4.0, aberta.</a:t>
+              <a:t>Arquivo: </a:t>
+            </a:r>
+            <a:r>
+              <a:rPr lang="pt-BR" sz="1200" b="0" i="0" dirty="0">
+                <a:solidFill>
+                  <a:srgbClr val="000000"/>
+                </a:solidFill>
+                <a:latin typeface="Poppins"/>
+                <a:ea typeface="Poppins"/>
+                <a:cs typeface="Poppins"/>
+              </a:rPr>
+              <a:t>data/cylab-commercial-v0.4-gold.jsonl (SHA-256 ea328aef…), público em </a:t>
+            </a:r>
+            <a:r>
+              <a:rPr lang="pt-BR" sz="1200" b="0" i="0" dirty="0">
+                <a:solidFill>
+                  <a:srgbClr val="2E6B57"/>
+                </a:solidFill>
+                <a:latin typeface="Poppins"/>
+                <a:ea typeface="Poppins"/>
+                <a:cs typeface="Poppins"/>
+                <a:hlinkClick r:id="rIdGh">
+                  <a:extLst>
+                    <a:ext uri="{A12FA001-AC4F-418D-AE19-62706E023703}">
+                      <ns0:hlinkClr xmlns:ns0="http://schemas.microsoft.com/office/drawing/2018/hyperlinkcolor" val="tx"/>
+                    </a:ext>
+                  </a:extLst>
+                </a:hlinkClick>
+              </a:rPr>
+              <a:t>github.com/ArthurAlcausa/cylab-dataset</a:t>
+            </a:r>
+            <a:r>
+              <a:rPr lang="pt-BR" sz="1200" b="0" i="0" dirty="0">
+                <a:solidFill>
+                  <a:srgbClr val="000000"/>
+                </a:solidFill>
+                <a:latin typeface="Poppins"/>
+                <a:ea typeface="Poppins"/>
+                <a:cs typeface="Poppins"/>
+              </a:rPr>
+              <a:t>. “commercial” vem da linha de escala (meta de ~2 mil pares na v0.2) e não restringe o uso: licença CC-BY-4.0, aberta.</a:t>
             </a:r>
           </a:p>
         </p:txBody>
@@ -5397,7 +4513,7 @@
                 <a:ea typeface="Poppins" pitchFamily="34" charset="-122"/>
                 <a:cs typeface="Poppins" pitchFamily="34" charset="-120"/>
               </a:rPr>
-              <a:t>7</a:t>
+              <a:t>8</a:t>
             </a:r>
             <a:endParaRPr lang="en-US" sz="1200" dirty="0"/>
           </a:p>
@@ -5412,7 +4528,7 @@
         <p:spPr>
           <a:xfrm>
             <a:off x="822960" y="2918764"/>
-            <a:ext cx="2194560" cy="2743200"/>
+            <a:ext cx="1554480" cy="2743200"/>
           </a:xfrm>
           <a:prstGeom prst="rect">
             <a:avLst/>
@@ -5431,8 +4547,8 @@
         </p:nvSpPr>
         <p:spPr>
           <a:xfrm>
-            <a:off x="3611880" y="5129851"/>
-            <a:ext cx="2194560" cy="532113"/>
+            <a:off x="2624328" y="5129784"/>
+            <a:ext cx="1554480" cy="532180"/>
           </a:xfrm>
           <a:prstGeom prst="rect">
             <a:avLst/>
@@ -5451,8 +4567,8 @@
         </p:nvSpPr>
         <p:spPr>
           <a:xfrm>
-            <a:off x="9189720" y="5065998"/>
-            <a:ext cx="2194560" cy="595966"/>
+            <a:off x="6227064" y="5065776"/>
+            <a:ext cx="1554480" cy="596188"/>
           </a:xfrm>
           <a:prstGeom prst="rect">
             <a:avLst/>
@@ -5465,14 +4581,34 @@
       </p:sp>
       <p:sp>
         <p:nvSpPr>
+          <p:cNvPr id="402" name="Bar 576"/>
+          <p:cNvSpPr/>
+          <p:nvPr/>
+        </p:nvSpPr>
+        <p:spPr>
+          <a:xfrm>
+            <a:off x="9829800" y="4940503"/>
+            <a:ext cx="1554480" cy="721461"/>
+          </a:xfrm>
+          <a:prstGeom prst="rect">
+            <a:avLst/>
+          </a:prstGeom>
+          <a:solidFill>
+            <a:srgbClr val="2E6B57"/>
+          </a:solidFill>
+          <a:ln/>
+        </p:spPr>
+      </p:sp>
+      <p:sp>
+        <p:nvSpPr>
           <p:cNvPr id="8" name="Shape 6"/>
           <p:cNvSpPr/>
           <p:nvPr/>
         </p:nvSpPr>
         <p:spPr>
           <a:xfrm>
-            <a:off x="6400800" y="5598111"/>
-            <a:ext cx="2194560" cy="63853"/>
+            <a:off x="4425696" y="5597956"/>
+            <a:ext cx="1554480" cy="64008"/>
           </a:xfrm>
           <a:prstGeom prst="rect">
             <a:avLst/>
@@ -5485,6 +4621,26 @@
       </p:sp>
       <p:sp>
         <p:nvSpPr>
+          <p:cNvPr id="401" name="Bar +100"/>
+          <p:cNvSpPr/>
+          <p:nvPr/>
+        </p:nvSpPr>
+        <p:spPr>
+          <a:xfrm>
+            <a:off x="8028431" y="5536692"/>
+            <a:ext cx="1554480" cy="125272"/>
+          </a:xfrm>
+          <a:prstGeom prst="rect">
+            <a:avLst/>
+          </a:prstGeom>
+          <a:solidFill>
+            <a:srgbClr val="CCCCCC"/>
+          </a:solidFill>
+          <a:ln/>
+        </p:spPr>
+      </p:sp>
+      <p:sp>
+        <p:nvSpPr>
           <p:cNvPr id="11" name="Text 9"/>
           <p:cNvSpPr/>
           <p:nvPr/>
@@ -5492,7 +4648,7 @@
         <p:spPr>
           <a:xfrm>
             <a:off x="822960" y="2415844"/>
-            <a:ext cx="2194560" cy="457200"/>
+            <a:ext cx="1554480" cy="457200"/>
           </a:xfrm>
           <a:prstGeom prst="rect">
             <a:avLst/>
@@ -5530,8 +4686,8 @@
         </p:nvSpPr>
         <p:spPr>
           <a:xfrm>
-            <a:off x="3611880" y="4626931"/>
-            <a:ext cx="2194560" cy="457200"/>
+            <a:off x="2624328" y="4626864"/>
+            <a:ext cx="1554480" cy="457200"/>
           </a:xfrm>
           <a:prstGeom prst="rect">
             <a:avLst/>
@@ -5569,8 +4725,8 @@
         </p:nvSpPr>
         <p:spPr>
           <a:xfrm>
-            <a:off x="9189720" y="4563078"/>
-            <a:ext cx="2194560" cy="457200"/>
+            <a:off x="6227064" y="4562856"/>
+            <a:ext cx="1554480" cy="457200"/>
           </a:xfrm>
           <a:prstGeom prst="rect">
             <a:avLst/>
@@ -5602,14 +4758,14 @@
       </p:sp>
       <p:sp>
         <p:nvSpPr>
-          <p:cNvPr id="14" name="Text 12"/>
-          <p:cNvSpPr/>
-          <p:nvPr/>
-        </p:nvSpPr>
-        <p:spPr>
-          <a:xfrm>
-            <a:off x="6400800" y="5095191"/>
-            <a:ext cx="2194560" cy="457200"/>
+          <p:cNvPr id="404" name="Value 576"/>
+          <p:cNvSpPr/>
+          <p:nvPr/>
+        </p:nvSpPr>
+        <p:spPr>
+          <a:xfrm>
+            <a:off x="9829800" y="4437583"/>
+            <a:ext cx="1554480" cy="457200"/>
           </a:xfrm>
           <a:prstGeom prst="rect">
             <a:avLst/>
@@ -5633,6 +4789,45 @@
                 <a:ea typeface="Lexend" pitchFamily="34" charset="-122"/>
                 <a:cs typeface="Lexend" pitchFamily="34" charset="-120"/>
               </a:rPr>
+              <a:t>576</a:t>
+            </a:r>
+            <a:endParaRPr lang="en-US" sz="1600" dirty="0"/>
+          </a:p>
+        </p:txBody>
+      </p:sp>
+      <p:sp>
+        <p:nvSpPr>
+          <p:cNvPr id="14" name="Text 12"/>
+          <p:cNvSpPr/>
+          <p:nvPr/>
+        </p:nvSpPr>
+        <p:spPr>
+          <a:xfrm>
+            <a:off x="4425696" y="5095036"/>
+            <a:ext cx="1554480" cy="457200"/>
+          </a:xfrm>
+          <a:prstGeom prst="rect">
+            <a:avLst/>
+          </a:prstGeom>
+          <a:noFill/>
+          <a:ln/>
+        </p:spPr>
+        <p:txBody>
+          <a:bodyPr wrap="square" rtlCol="0" anchor="t"/>
+          <a:lstStyle/>
+          <a:p>
+            <a:pPr algn="ctr" indent="0" marL="0">
+              <a:buNone/>
+            </a:pPr>
+            <a:r>
+              <a:rPr lang="en-US" sz="2400" dirty="0">
+                <a:solidFill>
+                  <a:srgbClr val="000000"/>
+                </a:solidFill>
+                <a:latin typeface="Lexend" pitchFamily="34" charset="0"/>
+                <a:ea typeface="Lexend" pitchFamily="34" charset="-122"/>
+                <a:cs typeface="Lexend" pitchFamily="34" charset="-120"/>
+              </a:rPr>
               <a:t>+51</a:t>
             </a:r>
             <a:endParaRPr lang="en-US" sz="1600" dirty="0"/>
@@ -5641,14 +4836,53 @@
       </p:sp>
       <p:sp>
         <p:nvSpPr>
+          <p:cNvPr id="403" name="Value +100"/>
+          <p:cNvSpPr/>
+          <p:nvPr/>
+        </p:nvSpPr>
+        <p:spPr>
+          <a:xfrm>
+            <a:off x="8028431" y="5033772"/>
+            <a:ext cx="1554480" cy="457200"/>
+          </a:xfrm>
+          <a:prstGeom prst="rect">
+            <a:avLst/>
+          </a:prstGeom>
+          <a:noFill/>
+          <a:ln/>
+        </p:spPr>
+        <p:txBody>
+          <a:bodyPr wrap="square" rtlCol="0" anchor="t"/>
+          <a:lstStyle/>
+          <a:p>
+            <a:pPr algn="ctr" indent="0" marL="0">
+              <a:buNone/>
+            </a:pPr>
+            <a:r>
+              <a:rPr lang="en-US" sz="2400" dirty="0">
+                <a:solidFill>
+                  <a:srgbClr val="000000"/>
+                </a:solidFill>
+                <a:latin typeface="Lexend" pitchFamily="34" charset="0"/>
+                <a:ea typeface="Lexend" pitchFamily="34" charset="-122"/>
+                <a:cs typeface="Lexend" pitchFamily="34" charset="-120"/>
+              </a:rPr>
+              <a:t>+100</a:t>
+            </a:r>
+            <a:endParaRPr lang="en-US" sz="1600" dirty="0"/>
+          </a:p>
+        </p:txBody>
+      </p:sp>
+      <p:sp>
+        <p:nvSpPr>
           <p:cNvPr id="15" name="Text 13"/>
           <p:cNvSpPr/>
           <p:nvPr/>
         </p:nvSpPr>
         <p:spPr>
           <a:xfrm>
-            <a:off x="3611880" y="2057400"/>
-            <a:ext cx="7772400" cy="914400"/>
+            <a:off x="2624328" y="2011680"/>
+            <a:ext cx="8759952" cy="685800"/>
           </a:xfrm>
           <a:prstGeom prst="rect">
             <a:avLst/>
@@ -5725,8 +4959,8 @@
         </p:nvSpPr>
         <p:spPr>
           <a:xfrm>
-            <a:off x="822960" y="5760720"/>
-            <a:ext cx="2194560" cy="365760"/>
+            <a:off x="822960" y="5742432"/>
+            <a:ext cx="1554480" cy="548640"/>
           </a:xfrm>
           <a:prstGeom prst="rect">
             <a:avLst/>
@@ -5764,8 +4998,8 @@
         </p:nvSpPr>
         <p:spPr>
           <a:xfrm>
-            <a:off x="3611880" y="5760720"/>
-            <a:ext cx="2194560" cy="365760"/>
+            <a:off x="2624328" y="5742432"/>
+            <a:ext cx="1554480" cy="548640"/>
           </a:xfrm>
           <a:prstGeom prst="rect">
             <a:avLst/>
@@ -5803,8 +5037,8 @@
         </p:nvSpPr>
         <p:spPr>
           <a:xfrm>
-            <a:off x="9189720" y="5760720"/>
-            <a:ext cx="2194560" cy="365760"/>
+            <a:off x="6227064" y="5742432"/>
+            <a:ext cx="1554480" cy="548640"/>
           </a:xfrm>
           <a:prstGeom prst="rect">
             <a:avLst/>
@@ -5836,14 +5070,14 @@
       </p:sp>
       <p:sp>
         <p:nvSpPr>
-          <p:cNvPr id="21" name="Text 19"/>
-          <p:cNvSpPr/>
-          <p:nvPr/>
-        </p:nvSpPr>
-        <p:spPr>
-          <a:xfrm>
-            <a:off x="6400800" y="5760720"/>
-            <a:ext cx="2194560" cy="365760"/>
+          <p:cNvPr id="406" name="Label v0.4-gold"/>
+          <p:cNvSpPr/>
+          <p:nvPr/>
+        </p:nvSpPr>
+        <p:spPr>
+          <a:xfrm>
+            <a:off x="9829800" y="5742432"/>
+            <a:ext cx="1554480" cy="548640"/>
           </a:xfrm>
           <a:prstGeom prst="rect">
             <a:avLst/>
@@ -5867,7 +5101,85 @@
                 <a:ea typeface="Lexend" pitchFamily="34" charset="-122"/>
                 <a:cs typeface="Lexend" pitchFamily="34" charset="-120"/>
               </a:rPr>
+              <a:t>v0.4-gold</a:t>
+            </a:r>
+            <a:endParaRPr lang="en-US" sz="1600" dirty="0"/>
+          </a:p>
+        </p:txBody>
+      </p:sp>
+      <p:sp>
+        <p:nvSpPr>
+          <p:cNvPr id="21" name="Text 19"/>
+          <p:cNvSpPr/>
+          <p:nvPr/>
+        </p:nvSpPr>
+        <p:spPr>
+          <a:xfrm>
+            <a:off x="4425696" y="5742432"/>
+            <a:ext cx="1554480" cy="548640"/>
+          </a:xfrm>
+          <a:prstGeom prst="rect">
+            <a:avLst/>
+          </a:prstGeom>
+          <a:noFill/>
+          <a:ln/>
+        </p:spPr>
+        <p:txBody>
+          <a:bodyPr wrap="square" rtlCol="0" anchor="t"/>
+          <a:lstStyle/>
+          <a:p>
+            <a:pPr algn="ctr" indent="0" marL="0">
+              <a:buNone/>
+            </a:pPr>
+            <a:r>
+              <a:rPr lang="en-US" sz="1400" dirty="0">
+                <a:solidFill>
+                  <a:srgbClr val="000000"/>
+                </a:solidFill>
+                <a:latin typeface="Lexend" pitchFamily="34" charset="0"/>
+                <a:ea typeface="Lexend" pitchFamily="34" charset="-122"/>
+                <a:cs typeface="Lexend" pitchFamily="34" charset="-120"/>
+              </a:rPr>
               <a:t>complemento</a:t>
+            </a:r>
+            <a:endParaRPr lang="en-US" sz="1600" dirty="0"/>
+          </a:p>
+        </p:txBody>
+      </p:sp>
+      <p:sp>
+        <p:nvSpPr>
+          <p:cNvPr id="405" name="Label realismo v0.4"/>
+          <p:cNvSpPr/>
+          <p:nvPr/>
+        </p:nvSpPr>
+        <p:spPr>
+          <a:xfrm>
+            <a:off x="8028431" y="5742432"/>
+            <a:ext cx="1554480" cy="548640"/>
+          </a:xfrm>
+          <a:prstGeom prst="rect">
+            <a:avLst/>
+          </a:prstGeom>
+          <a:noFill/>
+          <a:ln/>
+        </p:spPr>
+        <p:txBody>
+          <a:bodyPr wrap="square" rtlCol="0" anchor="t"/>
+          <a:lstStyle/>
+          <a:p>
+            <a:pPr algn="ctr" indent="0" marL="0">
+              <a:buNone/>
+            </a:pPr>
+            <a:r>
+              <a:rPr lang="en-US" sz="1400" dirty="0">
+                <a:solidFill>
+                  <a:srgbClr val="000000"/>
+                </a:solidFill>
+                <a:latin typeface="Lexend" pitchFamily="34" charset="0"/>
+                <a:ea typeface="Lexend" pitchFamily="34" charset="-122"/>
+                <a:cs typeface="Lexend" pitchFamily="34" charset="-120"/>
+              </a:rPr>
+              <a:t>realismo v0.4</a:t>
             </a:r>
             <a:endParaRPr lang="en-US" sz="1600" dirty="0"/>
           </a:p>
@@ -5953,8 +5265,8 @@
         </p:nvSpPr>
         <p:spPr>
           <a:xfrm>
-            <a:off x="3611880" y="3017520"/>
-            <a:ext cx="7772400" cy="1463040"/>
+            <a:off x="2624328" y="2743200"/>
+            <a:ext cx="8759952" cy="1645920"/>
           </a:xfrm>
           <a:prstGeom prst="rect">
             <a:avLst/>
@@ -6054,7 +5366,7 @@
                 <a:ea typeface="Poppins"/>
                 <a:cs typeface="Poppins"/>
               </a:rPr>
-              <a:t>Complemento +51: </a:t>
+              <a:t>Complemento +51 (v0.3): </a:t>
             </a:r>
             <a:r>
               <a:rPr lang="pt-BR" sz="1200" b="0" i="0" dirty="0">
@@ -6065,7 +5377,40 @@
                 <a:ea typeface="Poppins"/>
                 <a:cs typeface="Poppins"/>
               </a:rPr>
-              <a:t>nenhum é quase-duplicata dos pares já mantidos (Jaccard de 5-gramas ≥ 0,9; 181 descartados). Fonte: DOC_ACADEMICO_BANCA.md, § funil.</a:t>
+              <a:t>nenhum é quase-duplicata dos pares já mantidos (Jaccard de 5-gramas ≥ 0,9; 181 descartados).</a:t>
+            </a:r>
+          </a:p>
+          <a:p>
+            <a:pPr algn="l" indent="0" marL="0">
+              <a:lnSpc>
+                <a:spcPct val="115000"/>
+              </a:lnSpc>
+              <a:spcAft>
+                <a:spcPts val="0"/>
+              </a:spcAft>
+              <a:buNone/>
+            </a:pPr>
+            <a:r>
+              <a:rPr lang="pt-BR" sz="1200" b="1" i="0" dirty="0">
+                <a:solidFill>
+                  <a:srgbClr val="2E6B57"/>
+                </a:solidFill>
+                <a:latin typeface="Poppins"/>
+                <a:ea typeface="Poppins"/>
+                <a:cs typeface="Poppins"/>
+              </a:rPr>
+              <a:t>Realismo +100 (v0.4): </a:t>
+            </a:r>
+            <a:r>
+              <a:rPr lang="pt-BR" sz="1200" b="0" i="0" dirty="0">
+                <a:solidFill>
+                  <a:srgbClr val="000000"/>
+                </a:solidFill>
+                <a:latin typeface="Poppins"/>
+                <a:ea typeface="Poppins"/>
+                <a:cs typeface="Poppins"/>
+              </a:rPr>
+              <a:t>Jaccard de 4-gramas normalizados ≥ 0,85, por estrato; 0 descartados, nenhum agrupado com a v0.3; gate 100/100.</a:t>
             </a:r>
           </a:p>
         </p:txBody>
@@ -6173,7 +5518,7 @@
                 <a:ea typeface="Poppins" pitchFamily="34" charset="-122"/>
                 <a:cs typeface="Poppins" pitchFamily="34" charset="-120"/>
               </a:rPr>
-              <a:t>10</a:t>
+              <a:t>11</a:t>
             </a:r>
             <a:endParaRPr lang="en-US" sz="1200" dirty="0"/>
           </a:p>
@@ -6585,7 +5930,7 @@
                 <a:ea typeface="Poppins" pitchFamily="34" charset="-122"/>
                 <a:cs typeface="Poppins" pitchFamily="34" charset="-120"/>
               </a:rPr>
-              <a:t>Pares sintéticos e curtos: </a:t>
+              <a:t>Pares sintéticos, em maioria curtos: </a:t>
             </a:r>
             <a:r>
               <a:rPr lang="en-US" sz="1300" dirty="0">
@@ -6596,7 +5941,7 @@
                 <a:ea typeface="Poppins" pitchFamily="34" charset="-122"/>
                 <a:cs typeface="Poppins" pitchFamily="34" charset="-120"/>
               </a:rPr>
-              <a:t>mediana de 6 linhas no before; não representam código de produção com múltiplos arquivos. A deduplicação reduz a repetição, mas não muda essa natureza.</a:t>
+              <a:t>mediana de 6 linhas no before nos 576 pares. Os 100 pares de realismo da v0.4 têm de 26 a 52 linhas (mediana 35), mas são 17% do conjunto e de arquivo único.</a:t>
             </a:r>
             <a:endParaRPr lang="en-US" sz="1200" dirty="0"/>
           </a:p>
@@ -6630,7 +5975,7 @@
                 <a:ea typeface="Poppins" pitchFamily="34" charset="-122"/>
                 <a:cs typeface="Poppins" pitchFamily="34" charset="-120"/>
               </a:rPr>
-              <a:t>campo source normalizado no formato do schema (URL da CWE) nos 476 pares; validação do dataset OK.</a:t>
+              <a:t>campo source normalizado no formato do schema (URL da CWE) nos 576 pares; validação do dataset OK.</a:t>
             </a:r>
             <a:endParaRPr lang="en-US" sz="1200" dirty="0"/>
           </a:p>
@@ -6762,7 +6107,7 @@
                 <a:ea typeface="Poppins" pitchFamily="34" charset="-122"/>
                 <a:cs typeface="Poppins" pitchFamily="34" charset="-120"/>
               </a:rPr>
-              <a:t>11</a:t>
+              <a:t>6</a:t>
             </a:r>
             <a:endParaRPr lang="en-US" sz="1200" dirty="0"/>
           </a:p>
@@ -6801,7 +6146,7 @@
                 <a:ea typeface="Lexend" pitchFamily="34" charset="-122"/>
                 <a:cs typeface="Lexend" pitchFamily="34" charset="-120"/>
               </a:rPr>
-              <a:t>Próximos </a:t>
+              <a:t>Como montamos o </a:t>
             </a:r>
             <a:r>
               <a:rPr lang="en-US" sz="4400" dirty="0">
@@ -6812,7 +6157,7 @@
                 <a:ea typeface="Lexend" pitchFamily="34" charset="-122"/>
                 <a:cs typeface="Lexend" pitchFamily="34" charset="-120"/>
               </a:rPr>
-              <a:t>passos</a:t>
+              <a:t>dataset ouro</a:t>
             </a:r>
             <a:endParaRPr lang="en-US" sz="4400" dirty="0"/>
           </a:p>
@@ -6911,7 +6256,7 @@
                 <a:ea typeface="Lexend" pitchFamily="34" charset="-122"/>
                 <a:cs typeface="Lexend" pitchFamily="34" charset="-120"/>
               </a:rPr>
-              <a:t>1 · Ajuste fino</a:t>
+              <a:t>1 · Escrita + schema</a:t>
             </a:r>
             <a:endParaRPr lang="en-US" sz="1400" dirty="0"/>
           </a:p>
@@ -6953,7 +6298,7 @@
                 <a:ea typeface="Poppins" pitchFamily="34" charset="-122"/>
                 <a:cs typeface="Poppins" pitchFamily="34" charset="-120"/>
               </a:rPr>
-              <a:t>Qwen2.5-Coder-14B com LoRA/QLoRA; depois, um modelo maior da família Qwen.</a:t>
+              <a:t>Pares escritos do zero para a Cylab; o validador de esquema confere os 10 campos de cada registro.</a:t>
             </a:r>
             <a:endParaRPr lang="en-US" sz="1200" dirty="0"/>
           </a:p>
@@ -6992,7 +6337,7 @@
                 <a:ea typeface="Lexend" pitchFamily="34" charset="-122"/>
                 <a:cs typeface="Lexend" pitchFamily="34" charset="-120"/>
               </a:rPr>
-              <a:t>2 · Avaliação no holdout</a:t>
+              <a:t>2 · Dedup por estrato</a:t>
             </a:r>
             <a:endParaRPr lang="en-US" sz="1400" dirty="0"/>
           </a:p>
@@ -7034,7 +6379,7 @@
                 <a:ea typeface="Poppins" pitchFamily="34" charset="-122"/>
                 <a:cs typeface="Poppins" pitchFamily="34" charset="-120"/>
               </a:rPr>
-              <a:t>75 pares. Critério: o patch gerado passa no gate; revisão humana das explicações.</a:t>
+              <a:t>Jaccard (Broder) em 4-gramas de tokens, limiar 0,85, só dentro de linguagem + CWE. Sem MinHash.</a:t>
             </a:r>
             <a:endParaRPr lang="en-US" sz="1200" dirty="0"/>
           </a:p>
@@ -7073,7 +6418,7 @@
                 <a:ea typeface="Lexend" pitchFamily="34" charset="-122"/>
                 <a:cs typeface="Lexend" pitchFamily="34" charset="-120"/>
               </a:rPr>
-              <a:t>3 · Empacotamento local</a:t>
+              <a:t>3 · Gate rules-gold</a:t>
             </a:r>
             <a:endParaRPr lang="en-US" sz="1400" dirty="0"/>
           </a:p>
@@ -7115,7 +6460,7 @@
                 <a:ea typeface="Poppins" pitchFamily="34" charset="-122"/>
                 <a:cs typeface="Poppins" pitchFamily="34" charset="-120"/>
               </a:rPr>
-              <a:t>Modelo servido via Ollama, com CLI e extensão para o VS Code.</a:t>
+              <a:t>A regra dá ≥ 1 achado no before e = 0 no after. v0.4-gold: 576/576.</a:t>
             </a:r>
             <a:endParaRPr lang="en-US" sz="1200" dirty="0"/>
           </a:p>
@@ -7154,7 +6499,7 @@
                 <a:ea typeface="Lexend" pitchFamily="34" charset="-122"/>
                 <a:cs typeface="Lexend" pitchFamily="34" charset="-120"/>
               </a:rPr>
-              <a:t>Pergunta da próxima entrega</a:t>
+              <a:t>Critério de partição</a:t>
             </a:r>
             <a:endParaRPr lang="en-US" sz="1600" dirty="0"/>
           </a:p>
@@ -7196,7 +6541,7 @@
                 <a:ea typeface="Poppins" pitchFamily="34" charset="-122"/>
                 <a:cs typeface="Poppins" pitchFamily="34" charset="-120"/>
               </a:rPr>
-              <a:t>Um modelo local, treinado nesses pares, gera patches que passam no gate?</a:t>
+              <a:t>Train/holdout só depois do dedup: 489 treino, 87 holdout no v0.4-gold.</a:t>
             </a:r>
             <a:endParaRPr lang="en-US" sz="1200" dirty="0"/>
           </a:p>
@@ -7238,7 +6583,656 @@
                 <a:ea typeface="Poppins" pitchFamily="34" charset="-122"/>
                 <a:cs typeface="Poppins" pitchFamily="34" charset="-120"/>
               </a:rPr>
-              <a:t>Também: incluir funções maiores e casos com múltiplos arquivos; reavaliar o taint em C/C++ quando houver suporte.</a:t>
+              <a:t>Antes do dedup, o código é normalizado: sem comentários; literais, números e identificadores viram marcadores.</a:t>
+            </a:r>
+            <a:endParaRPr lang="en-US" sz="1200" dirty="0"/>
+          </a:p>
+        </p:txBody>
+      </p:sp>
+      <p:sp>
+        <p:nvSpPr>
+          <p:cNvPr id="19" name="Text 17"/>
+          <p:cNvSpPr/>
+          <p:nvPr/>
+        </p:nvSpPr>
+        <p:spPr>
+          <a:xfrm>
+            <a:off x="8143646" y="3154680"/>
+            <a:ext cx="2824582" cy="822960"/>
+          </a:xfrm>
+          <a:prstGeom prst="rect">
+            <a:avLst/>
+          </a:prstGeom>
+          <a:noFill/>
+          <a:ln/>
+        </p:spPr>
+        <p:txBody>
+          <a:bodyPr wrap="square" rtlCol="0" anchor="t"/>
+          <a:lstStyle/>
+          <a:p>
+            <a:pPr algn="l" indent="0" marL="0">
+              <a:lnSpc>
+                <a:spcPct val="130000"/>
+              </a:lnSpc>
+              <a:buNone/>
+            </a:pPr>
+            <a:r>
+              <a:rPr lang="en-US" sz="1200" dirty="0">
+                <a:solidFill>
+                  <a:srgbClr val="000000"/>
+                </a:solidFill>
+                <a:latin typeface="Poppins" pitchFamily="34" charset="0"/>
+                <a:ea typeface="Poppins" pitchFamily="34" charset="-122"/>
+                <a:cs typeface="Poppins" pitchFamily="34" charset="-120"/>
+              </a:rPr>
+              <a:t>Cada etapa deixa relatório e SHA-256 em data/, para auditoria.</a:t>
+            </a:r>
+            <a:endParaRPr lang="en-US" sz="1200" dirty="0"/>
+          </a:p>
+        </p:txBody>
+      </p:sp>
+      <p:sp>
+        <p:nvSpPr>
+          <p:cNvPr id="60" name="Shape 58"/>
+          <p:cNvSpPr/>
+          <p:nvPr/>
+        </p:nvSpPr>
+        <p:spPr>
+          <a:xfrm>
+            <a:off x="4069080" y="1810512"/>
+            <a:ext cx="1273759" cy="102413"/>
+          </a:xfrm>
+          <a:prstGeom prst="roundRect">
+            <a:avLst>
+              <a:gd name="adj" fmla="val 50000"/>
+            </a:avLst>
+          </a:prstGeom>
+          <a:solidFill>
+            <a:srgbClr val="2E6B57"/>
+          </a:solidFill>
+          <a:ln/>
+        </p:spPr>
+      </p:sp>
+    </p:spTree>
+  </p:cSld>
+  <p:clrMapOvr>
+    <a:masterClrMapping/>
+  </p:clrMapOvr>
+</p:sld>
+</file>
+
+<file path=ppt/slides/slide19.xml><?xml version="1.0" encoding="utf-8"?>
+<p:sld xmlns:a="http://schemas.openxmlformats.org/drawingml/2006/main" xmlns:r="http://schemas.openxmlformats.org/officeDocument/2006/relationships" xmlns:p="http://schemas.openxmlformats.org/presentationml/2006/main">
+  <p:cSld name="Slide 12">
+    <p:spTree>
+      <p:nvGrpSpPr>
+        <p:cNvPr id="1" name=""/>
+        <p:cNvGrpSpPr/>
+        <p:nvPr/>
+      </p:nvGrpSpPr>
+      <p:grpSpPr>
+        <a:xfrm>
+          <a:off x="0" y="0"/>
+          <a:ext cx="0" cy="0"/>
+          <a:chOff x="0" y="0"/>
+          <a:chExt cx="0" cy="0"/>
+        </a:xfrm>
+      </p:grpSpPr>
+      <p:sp>
+        <p:nvSpPr>
+          <p:cNvPr id="2" name="Text 0"/>
+          <p:cNvSpPr/>
+          <p:nvPr/>
+        </p:nvSpPr>
+        <p:spPr>
+          <a:xfrm>
+            <a:off x="394106" y="228600"/>
+            <a:ext cx="2920594" cy="309067"/>
+          </a:xfrm>
+          <a:prstGeom prst="rect">
+            <a:avLst/>
+          </a:prstGeom>
+          <a:noFill/>
+          <a:ln/>
+        </p:spPr>
+        <p:txBody>
+          <a:bodyPr wrap="square" rtlCol="0" anchor="t"/>
+          <a:lstStyle/>
+          <a:p>
+            <a:pPr indent="0" marL="0">
+              <a:lnSpc>
+                <a:spcPct val="130000"/>
+              </a:lnSpc>
+              <a:buNone/>
+            </a:pPr>
+            <a:r>
+              <a:rPr lang="en-US" sz="1200" dirty="0">
+                <a:solidFill>
+                  <a:srgbClr val="000000"/>
+                </a:solidFill>
+                <a:latin typeface="Lexend" pitchFamily="34" charset="0"/>
+                <a:ea typeface="Lexend" pitchFamily="34" charset="-122"/>
+                <a:cs typeface="Lexend" pitchFamily="34" charset="-120"/>
+              </a:rPr>
+              <a:t>Cylab · PUC Campinas</a:t>
+            </a:r>
+            <a:endParaRPr lang="en-US" sz="1200" dirty="0"/>
+          </a:p>
+        </p:txBody>
+      </p:sp>
+      <p:sp>
+        <p:nvSpPr>
+          <p:cNvPr id="4" name="Text 2"/>
+          <p:cNvSpPr/>
+          <p:nvPr/>
+        </p:nvSpPr>
+        <p:spPr>
+          <a:xfrm>
+            <a:off x="8876995" y="6320333"/>
+            <a:ext cx="2920594" cy="312725"/>
+          </a:xfrm>
+          <a:prstGeom prst="rect">
+            <a:avLst/>
+          </a:prstGeom>
+          <a:noFill/>
+          <a:ln/>
+        </p:spPr>
+        <p:txBody>
+          <a:bodyPr wrap="square" rtlCol="0" anchor="t"/>
+          <a:lstStyle/>
+          <a:p>
+            <a:pPr algn="r" indent="0" marL="0">
+              <a:lnSpc>
+                <a:spcPct val="130000"/>
+              </a:lnSpc>
+              <a:buNone/>
+            </a:pPr>
+            <a:r>
+              <a:rPr lang="en-US" sz="1200" dirty="0">
+                <a:solidFill>
+                  <a:srgbClr val="000000"/>
+                </a:solidFill>
+                <a:latin typeface="Poppins" pitchFamily="34" charset="0"/>
+                <a:ea typeface="Poppins" pitchFamily="34" charset="-122"/>
+                <a:cs typeface="Poppins" pitchFamily="34" charset="-120"/>
+              </a:rPr>
+              <a:t>12</a:t>
+            </a:r>
+            <a:endParaRPr lang="en-US" sz="1200" dirty="0"/>
+          </a:p>
+        </p:txBody>
+      </p:sp>
+      <p:sp>
+        <p:nvSpPr>
+          <p:cNvPr id="5" name="Text 3"/>
+          <p:cNvSpPr/>
+          <p:nvPr/>
+        </p:nvSpPr>
+        <p:spPr>
+          <a:xfrm>
+            <a:off x="702259" y="978408"/>
+            <a:ext cx="10394899" cy="769010"/>
+          </a:xfrm>
+          <a:prstGeom prst="rect">
+            <a:avLst/>
+          </a:prstGeom>
+          <a:noFill/>
+          <a:ln/>
+        </p:spPr>
+        <p:txBody>
+          <a:bodyPr wrap="square" rtlCol="0" anchor="t"/>
+          <a:lstStyle/>
+          <a:p>
+            <a:pPr algn="l" indent="0" marL="0">
+              <a:buNone/>
+            </a:pPr>
+            <a:r>
+              <a:rPr lang="en-US" sz="4400" dirty="0">
+                <a:solidFill>
+                  <a:srgbClr val="000000"/>
+                </a:solidFill>
+                <a:latin typeface="Lexend" pitchFamily="34" charset="0"/>
+                <a:ea typeface="Lexend" pitchFamily="34" charset="-122"/>
+                <a:cs typeface="Lexend" pitchFamily="34" charset="-120"/>
+              </a:rPr>
+              <a:t>Próximos </a:t>
+            </a:r>
+            <a:r>
+              <a:rPr lang="en-US" sz="4400" dirty="0">
+                <a:solidFill>
+                  <a:srgbClr val="2E6B57"/>
+                </a:solidFill>
+                <a:latin typeface="Lexend" pitchFamily="34" charset="0"/>
+                <a:ea typeface="Lexend" pitchFamily="34" charset="-122"/>
+                <a:cs typeface="Lexend" pitchFamily="34" charset="-120"/>
+              </a:rPr>
+              <a:t>passos</a:t>
+            </a:r>
+            <a:endParaRPr lang="en-US" sz="4400" dirty="0"/>
+          </a:p>
+        </p:txBody>
+      </p:sp>
+      <p:sp>
+        <p:nvSpPr>
+          <p:cNvPr id="6" name="Shape 4"/>
+          <p:cNvSpPr/>
+          <p:nvPr/>
+        </p:nvSpPr>
+        <p:spPr>
+          <a:xfrm>
+            <a:off x="702259" y="2180844"/>
+            <a:ext cx="2962656" cy="2085746"/>
+          </a:xfrm>
+          <a:prstGeom prst="rect">
+            <a:avLst/>
+          </a:prstGeom>
+          <a:solidFill>
+            <a:srgbClr val="2E6B57"/>
+          </a:solidFill>
+          <a:ln/>
+        </p:spPr>
+      </p:sp>
+      <p:sp>
+        <p:nvSpPr>
+          <p:cNvPr id="7" name="Shape 5"/>
+          <p:cNvSpPr/>
+          <p:nvPr/>
+        </p:nvSpPr>
+        <p:spPr>
+          <a:xfrm>
+            <a:off x="4422953" y="3224174"/>
+            <a:ext cx="2962656" cy="2085746"/>
+          </a:xfrm>
+          <a:prstGeom prst="rect">
+            <a:avLst/>
+          </a:prstGeom>
+          <a:solidFill>
+            <a:srgbClr val="1F2A27"/>
+          </a:solidFill>
+          <a:ln/>
+        </p:spPr>
+      </p:sp>
+      <p:sp>
+        <p:nvSpPr>
+          <p:cNvPr id="8" name="Shape 6"/>
+          <p:cNvSpPr/>
+          <p:nvPr/>
+        </p:nvSpPr>
+        <p:spPr>
+          <a:xfrm>
+            <a:off x="8143646" y="4267505"/>
+            <a:ext cx="2962656" cy="2085746"/>
+          </a:xfrm>
+          <a:prstGeom prst="rect">
+            <a:avLst/>
+          </a:prstGeom>
+          <a:solidFill>
+            <a:srgbClr val="CCCCCC"/>
+          </a:solidFill>
+          <a:ln/>
+        </p:spPr>
+      </p:sp>
+      <p:sp>
+        <p:nvSpPr>
+          <p:cNvPr id="9" name="Text 7"/>
+          <p:cNvSpPr/>
+          <p:nvPr/>
+        </p:nvSpPr>
+        <p:spPr>
+          <a:xfrm>
+            <a:off x="910742" y="2538374"/>
+            <a:ext cx="2651760" cy="384048"/>
+          </a:xfrm>
+          <a:prstGeom prst="rect">
+            <a:avLst/>
+          </a:prstGeom>
+          <a:noFill/>
+          <a:ln/>
+        </p:spPr>
+        <p:txBody>
+          <a:bodyPr wrap="square" rtlCol="0" anchor="t"/>
+          <a:lstStyle/>
+          <a:p>
+            <a:pPr algn="l" indent="0" marL="0">
+              <a:buNone/>
+            </a:pPr>
+            <a:r>
+              <a:rPr lang="en-US" sz="1600" dirty="0">
+                <a:solidFill>
+                  <a:srgbClr val="F5F3EF"/>
+                </a:solidFill>
+                <a:latin typeface="Lexend" pitchFamily="34" charset="0"/>
+                <a:ea typeface="Lexend" pitchFamily="34" charset="-122"/>
+                <a:cs typeface="Lexend" pitchFamily="34" charset="-120"/>
+              </a:rPr>
+              <a:t>1 · Ajuste fino</a:t>
+            </a:r>
+            <a:endParaRPr lang="en-US" sz="1400" dirty="0"/>
+          </a:p>
+        </p:txBody>
+      </p:sp>
+      <p:sp>
+        <p:nvSpPr>
+          <p:cNvPr id="10" name="Text 8"/>
+          <p:cNvSpPr/>
+          <p:nvPr/>
+        </p:nvSpPr>
+        <p:spPr>
+          <a:xfrm>
+            <a:off x="910742" y="2995574"/>
+            <a:ext cx="2697480" cy="914400"/>
+          </a:xfrm>
+          <a:prstGeom prst="rect">
+            <a:avLst/>
+          </a:prstGeom>
+          <a:noFill/>
+          <a:ln/>
+        </p:spPr>
+        <p:txBody>
+          <a:bodyPr wrap="square" rtlCol="0" anchor="t"/>
+          <a:lstStyle/>
+          <a:p>
+            <a:pPr algn="l" indent="0" marL="0">
+              <a:lnSpc>
+                <a:spcPct val="130000"/>
+              </a:lnSpc>
+              <a:buNone/>
+            </a:pPr>
+            <a:r>
+              <a:rPr lang="en-US" sz="1200" dirty="0">
+                <a:solidFill>
+                  <a:srgbClr val="F5F3EF"/>
+                </a:solidFill>
+                <a:latin typeface="Poppins" pitchFamily="34" charset="0"/>
+                <a:ea typeface="Poppins" pitchFamily="34" charset="-122"/>
+                <a:cs typeface="Poppins" pitchFamily="34" charset="-120"/>
+              </a:rPr>
+              <a:t>Qwen2.5-Coder-14B com LoRA/QLoRA; depois, um modelo maior da família Qwen.</a:t>
+            </a:r>
+            <a:endParaRPr lang="en-US" sz="1200" dirty="0"/>
+          </a:p>
+        </p:txBody>
+      </p:sp>
+      <p:sp>
+        <p:nvSpPr>
+          <p:cNvPr id="11" name="Text 9"/>
+          <p:cNvSpPr/>
+          <p:nvPr/>
+        </p:nvSpPr>
+        <p:spPr>
+          <a:xfrm>
+            <a:off x="4631436" y="3581704"/>
+            <a:ext cx="2651760" cy="384048"/>
+          </a:xfrm>
+          <a:prstGeom prst="rect">
+            <a:avLst/>
+          </a:prstGeom>
+          <a:noFill/>
+          <a:ln/>
+        </p:spPr>
+        <p:txBody>
+          <a:bodyPr wrap="square" rtlCol="0" anchor="t"/>
+          <a:lstStyle/>
+          <a:p>
+            <a:pPr algn="l" indent="0" marL="0">
+              <a:buNone/>
+            </a:pPr>
+            <a:r>
+              <a:rPr lang="en-US" sz="1600" dirty="0">
+                <a:solidFill>
+                  <a:srgbClr val="F5F3EF"/>
+                </a:solidFill>
+                <a:latin typeface="Lexend" pitchFamily="34" charset="0"/>
+                <a:ea typeface="Lexend" pitchFamily="34" charset="-122"/>
+                <a:cs typeface="Lexend" pitchFamily="34" charset="-120"/>
+              </a:rPr>
+              <a:t>2 · Avaliação no holdout</a:t>
+            </a:r>
+            <a:endParaRPr lang="en-US" sz="1400" dirty="0"/>
+          </a:p>
+        </p:txBody>
+      </p:sp>
+      <p:sp>
+        <p:nvSpPr>
+          <p:cNvPr id="12" name="Text 10"/>
+          <p:cNvSpPr/>
+          <p:nvPr/>
+        </p:nvSpPr>
+        <p:spPr>
+          <a:xfrm>
+            <a:off x="4631436" y="4038904"/>
+            <a:ext cx="2697480" cy="914400"/>
+          </a:xfrm>
+          <a:prstGeom prst="rect">
+            <a:avLst/>
+          </a:prstGeom>
+          <a:noFill/>
+          <a:ln/>
+        </p:spPr>
+        <p:txBody>
+          <a:bodyPr wrap="square" rtlCol="0" anchor="t"/>
+          <a:lstStyle/>
+          <a:p>
+            <a:pPr algn="l" indent="0" marL="0">
+              <a:lnSpc>
+                <a:spcPct val="130000"/>
+              </a:lnSpc>
+              <a:buNone/>
+            </a:pPr>
+            <a:r>
+              <a:rPr lang="en-US" sz="1200" dirty="0">
+                <a:solidFill>
+                  <a:srgbClr val="F5F3EF"/>
+                </a:solidFill>
+                <a:latin typeface="Poppins" pitchFamily="34" charset="0"/>
+                <a:ea typeface="Poppins" pitchFamily="34" charset="-122"/>
+                <a:cs typeface="Poppins" pitchFamily="34" charset="-120"/>
+              </a:rPr>
+              <a:t>87 pares do holdout v0.4-gold. Critério: o patch gerado passa no gate; revisão humana das explicações.</a:t>
+            </a:r>
+            <a:endParaRPr lang="en-US" sz="1200" dirty="0"/>
+          </a:p>
+        </p:txBody>
+      </p:sp>
+      <p:sp>
+        <p:nvSpPr>
+          <p:cNvPr id="13" name="Text 11"/>
+          <p:cNvSpPr/>
+          <p:nvPr/>
+        </p:nvSpPr>
+        <p:spPr>
+          <a:xfrm>
+            <a:off x="8352130" y="4625035"/>
+            <a:ext cx="2651760" cy="384048"/>
+          </a:xfrm>
+          <a:prstGeom prst="rect">
+            <a:avLst/>
+          </a:prstGeom>
+          <a:noFill/>
+          <a:ln/>
+        </p:spPr>
+        <p:txBody>
+          <a:bodyPr wrap="square" rtlCol="0" anchor="t"/>
+          <a:lstStyle/>
+          <a:p>
+            <a:pPr algn="l" indent="0" marL="0">
+              <a:buNone/>
+            </a:pPr>
+            <a:r>
+              <a:rPr lang="en-US" sz="1600" dirty="0">
+                <a:solidFill>
+                  <a:srgbClr val="000000"/>
+                </a:solidFill>
+                <a:latin typeface="Lexend" pitchFamily="34" charset="0"/>
+                <a:ea typeface="Lexend" pitchFamily="34" charset="-122"/>
+                <a:cs typeface="Lexend" pitchFamily="34" charset="-120"/>
+              </a:rPr>
+              <a:t>3 · Empacotamento local</a:t>
+            </a:r>
+            <a:endParaRPr lang="en-US" sz="1400" dirty="0"/>
+          </a:p>
+        </p:txBody>
+      </p:sp>
+      <p:sp>
+        <p:nvSpPr>
+          <p:cNvPr id="14" name="Text 12"/>
+          <p:cNvSpPr/>
+          <p:nvPr/>
+        </p:nvSpPr>
+        <p:spPr>
+          <a:xfrm>
+            <a:off x="8352130" y="5082235"/>
+            <a:ext cx="2697480" cy="914400"/>
+          </a:xfrm>
+          <a:prstGeom prst="rect">
+            <a:avLst/>
+          </a:prstGeom>
+          <a:noFill/>
+          <a:ln/>
+        </p:spPr>
+        <p:txBody>
+          <a:bodyPr wrap="square" rtlCol="0" anchor="t"/>
+          <a:lstStyle/>
+          <a:p>
+            <a:pPr algn="l" indent="0" marL="0">
+              <a:lnSpc>
+                <a:spcPct val="130000"/>
+              </a:lnSpc>
+              <a:buNone/>
+            </a:pPr>
+            <a:r>
+              <a:rPr lang="en-US" sz="1200" dirty="0">
+                <a:solidFill>
+                  <a:srgbClr val="000000"/>
+                </a:solidFill>
+                <a:latin typeface="Poppins" pitchFamily="34" charset="0"/>
+                <a:ea typeface="Poppins" pitchFamily="34" charset="-122"/>
+                <a:cs typeface="Poppins" pitchFamily="34" charset="-120"/>
+              </a:rPr>
+              <a:t>Modelo servido via Ollama, com CLI e extensão para o VS Code.</a:t>
+            </a:r>
+            <a:endParaRPr lang="en-US" sz="1200" dirty="0"/>
+          </a:p>
+        </p:txBody>
+      </p:sp>
+      <p:sp>
+        <p:nvSpPr>
+          <p:cNvPr id="15" name="Text 13"/>
+          <p:cNvSpPr/>
+          <p:nvPr/>
+        </p:nvSpPr>
+        <p:spPr>
+          <a:xfrm>
+            <a:off x="4422952" y="2011680"/>
+            <a:ext cx="3566160" cy="338328"/>
+          </a:xfrm>
+          <a:prstGeom prst="rect">
+            <a:avLst/>
+          </a:prstGeom>
+          <a:noFill/>
+          <a:ln/>
+        </p:spPr>
+        <p:txBody>
+          <a:bodyPr wrap="square" rtlCol="0" anchor="t"/>
+          <a:lstStyle/>
+          <a:p>
+            <a:pPr algn="l" indent="0" marL="0">
+              <a:buNone/>
+            </a:pPr>
+            <a:r>
+              <a:rPr lang="en-US" sz="1600" dirty="0">
+                <a:solidFill>
+                  <a:srgbClr val="000000"/>
+                </a:solidFill>
+                <a:latin typeface="Lexend" pitchFamily="34" charset="0"/>
+                <a:ea typeface="Lexend" pitchFamily="34" charset="-122"/>
+                <a:cs typeface="Lexend" pitchFamily="34" charset="-120"/>
+              </a:rPr>
+              <a:t>Pergunta da próxima entrega</a:t>
+            </a:r>
+            <a:endParaRPr lang="en-US" sz="1600" dirty="0"/>
+          </a:p>
+        </p:txBody>
+      </p:sp>
+      <p:sp>
+        <p:nvSpPr>
+          <p:cNvPr id="16" name="Text 14"/>
+          <p:cNvSpPr/>
+          <p:nvPr/>
+        </p:nvSpPr>
+        <p:spPr>
+          <a:xfrm>
+            <a:off x="4422952" y="2359152"/>
+            <a:ext cx="3566160" cy="731520"/>
+          </a:xfrm>
+          <a:prstGeom prst="rect">
+            <a:avLst/>
+          </a:prstGeom>
+          <a:noFill/>
+          <a:ln/>
+        </p:spPr>
+        <p:txBody>
+          <a:bodyPr wrap="square" rtlCol="0" anchor="t"/>
+          <a:lstStyle/>
+          <a:p>
+            <a:pPr algn="l" indent="0" marL="0">
+              <a:lnSpc>
+                <a:spcPct val="130000"/>
+              </a:lnSpc>
+              <a:buNone/>
+            </a:pPr>
+            <a:r>
+              <a:rPr lang="en-US" sz="1300" dirty="0">
+                <a:solidFill>
+                  <a:srgbClr val="000000"/>
+                </a:solidFill>
+                <a:latin typeface="Poppins" pitchFamily="34" charset="0"/>
+                <a:ea typeface="Poppins" pitchFamily="34" charset="-122"/>
+                <a:cs typeface="Poppins" pitchFamily="34" charset="-120"/>
+              </a:rPr>
+              <a:t>Um modelo local, treinado nesses pares, gera patches que passam no gate?</a:t>
+            </a:r>
+            <a:endParaRPr lang="en-US" sz="1200" dirty="0"/>
+          </a:p>
+        </p:txBody>
+      </p:sp>
+      <p:sp>
+        <p:nvSpPr>
+          <p:cNvPr id="18" name="Text 16"/>
+          <p:cNvSpPr/>
+          <p:nvPr/>
+        </p:nvSpPr>
+        <p:spPr>
+          <a:xfrm>
+            <a:off x="702259" y="4434840"/>
+            <a:ext cx="2824582" cy="1280160"/>
+          </a:xfrm>
+          <a:prstGeom prst="rect">
+            <a:avLst/>
+          </a:prstGeom>
+          <a:noFill/>
+          <a:ln/>
+        </p:spPr>
+        <p:txBody>
+          <a:bodyPr wrap="square" rtlCol="0" anchor="t"/>
+          <a:lstStyle/>
+          <a:p>
+            <a:pPr algn="l" indent="0" marL="0">
+              <a:lnSpc>
+                <a:spcPct val="130000"/>
+              </a:lnSpc>
+              <a:buNone/>
+            </a:pPr>
+            <a:r>
+              <a:rPr lang="en-US" sz="1200" dirty="0">
+                <a:solidFill>
+                  <a:srgbClr val="000000"/>
+                </a:solidFill>
+                <a:latin typeface="Poppins" pitchFamily="34" charset="0"/>
+                <a:ea typeface="Poppins" pitchFamily="34" charset="-122"/>
+                <a:cs typeface="Poppins" pitchFamily="34" charset="-120"/>
+              </a:rPr>
+              <a:t>Também: mais pares longos, na linha do buffer de realismo, e casos com múltiplos arquivos; reavaliar o taint em C/C++ quando houver suporte.</a:t>
             </a:r>
             <a:endParaRPr lang="en-US" sz="1200" dirty="0"/>
           </a:p>
@@ -7895,7 +7889,7 @@
                 <a:ea typeface="Poppins" pitchFamily="34" charset="-122"/>
                 <a:cs typeface="Poppins" pitchFamily="34" charset="-120"/>
               </a:rPr>
-              <a:t>13</a:t>
+              <a:t>14</a:t>
             </a:r>
             <a:endParaRPr lang="en-US" sz="1200" dirty="0"/>
           </a:p>
@@ -8003,8 +7997,8 @@
         </p:nvSpPr>
         <p:spPr>
           <a:xfrm>
-            <a:off x="7433158" y="3981298"/>
-            <a:ext cx="4080967" cy="2213762"/>
+            <a:off x="7433158" y="3429000"/>
+            <a:ext cx="4080967" cy="2766060"/>
           </a:xfrm>
           <a:prstGeom prst="roundRect">
             <a:avLst>
@@ -8360,8 +8354,8 @@
         </p:nvSpPr>
         <p:spPr>
           <a:xfrm>
-            <a:off x="7674559" y="4069080"/>
-            <a:ext cx="3613709" cy="1554480"/>
+            <a:off x="7674559" y="3538728"/>
+            <a:ext cx="3613709" cy="2057400"/>
           </a:xfrm>
           <a:prstGeom prst="rect">
             <a:avLst/>
@@ -8391,7 +8385,35 @@
                 <a:ea typeface="Poppins" pitchFamily="34" charset="-122"/>
                 <a:cs typeface="Poppins" pitchFamily="34" charset="-120"/>
               </a:rPr>
-              <a:t>CYLAB. Conjunto v0.3-gold, 476 registros, CC-BY-4.0: data/cylab-commercial-v0.3-gold.jsonl</a:t>
+              <a:t>CYLAB. Repositório público:</a:t>
+            </a:r>
+            <a:br>
+              <a:rPr lang="en-US" sz="1050" dirty="0">
+                <a:solidFill>
+                  <a:srgbClr val="F5F3EF"/>
+                </a:solidFill>
+                <a:latin typeface="Poppins" pitchFamily="34" charset="0"/>
+                <a:ea typeface="Poppins" pitchFamily="34" charset="-122"/>
+                <a:cs typeface="Poppins" pitchFamily="34" charset="-120"/>
+              </a:rPr>
+            </a:br>
+            <a:r>
+              <a:rPr lang="en-US" sz="1050" dirty="0">
+                <a:solidFill>
+                  <a:srgbClr val="F5F3EF"/>
+                </a:solidFill>
+                <a:latin typeface="Poppins" pitchFamily="34" charset="0"/>
+                <a:ea typeface="Poppins" pitchFamily="34" charset="-122"/>
+                <a:cs typeface="Poppins" pitchFamily="34" charset="-120"/>
+                <a:hlinkClick r:id="rIdGh">
+                  <a:extLst>
+                    <a:ext uri="{A12FA001-AC4F-418D-AE19-62706E023703}">
+                      <ns0:hlinkClr xmlns:ns0="http://schemas.microsoft.com/office/drawing/2018/hyperlinkcolor" val="tx"/>
+                    </a:ext>
+                  </a:extLst>
+                </a:hlinkClick>
+              </a:rPr>
+              <a:t>github.com/ArthurAlcausa/cylab-dataset</a:t>
             </a:r>
             <a:endParaRPr lang="en-US" sz="1200" dirty="0"/>
           </a:p>
@@ -8414,7 +8436,7 @@
                 <a:ea typeface="Poppins" pitchFamily="34" charset="-122"/>
                 <a:cs typeface="Poppins" pitchFamily="34" charset="-120"/>
               </a:rPr>
-              <a:t>CYLAB. Registro de progresso, chave gold_final: data/gold-progress.json</a:t>
+              <a:t>CYLAB. v0.4-gold, 576 registros, CC-BY-4.0: data/cylab-commercial-v0.4-gold.jsonl (SHA-256 ea328aef…)</a:t>
             </a:r>
             <a:endParaRPr lang="en-US" sz="1200" dirty="0"/>
           </a:p>
@@ -8437,10 +8459,33 @@
                 <a:ea typeface="Poppins" pitchFamily="34" charset="-122"/>
                 <a:cs typeface="Poppins" pitchFamily="34" charset="-120"/>
               </a:rPr>
-              <a:t>CYLAB. Regras endurecidas e gate: rules-gold/; scripts/gate_draft.py</a:t>
+              <a:t>CYLAB. v0.3-gold, 476 registros, intacto: data/cylab-commercial-v0.3-gold.jsonl (SHA-256 f37e1316…)</a:t>
             </a:r>
             <a:endParaRPr lang="en-US" sz="1200" dirty="0"/>
           </a:p>
+          <a:p>
+            <a:pPr algn="l" indent="0" marL="0">
+              <a:lnSpc>
+                <a:spcPct val="130000"/>
+              </a:lnSpc>
+              <a:spcAft>
+                <a:spcPts val="300"/>
+              </a:spcAft>
+              <a:buNone/>
+            </a:pPr>
+            <a:r>
+              <a:rPr lang="en-US" sz="1050" dirty="0">
+                <a:solidFill>
+                  <a:srgbClr val="F5F3EF"/>
+                </a:solidFill>
+                <a:latin typeface="Poppins" pitchFamily="34" charset="0"/>
+                <a:ea typeface="Poppins" pitchFamily="34" charset="-122"/>
+                <a:cs typeface="Poppins" pitchFamily="34" charset="-120"/>
+              </a:rPr>
+              <a:t>CYLAB. Regras e gate: rules-gold/; scripts/gate_gold.py</a:t>
+            </a:r>
+            <a:endParaRPr lang="en-US" sz="1200" dirty="0"/>
+          </a:p>
         </p:txBody>
       </p:sp>
       <p:sp>
@@ -8452,7 +8497,7 @@
         <p:spPr>
           <a:xfrm>
             <a:off x="7433157" y="1828800"/>
-            <a:ext cx="4206240" cy="2011680"/>
+            <a:ext cx="4206240" cy="1554480"/>
           </a:xfrm>
           <a:prstGeom prst="rect">
             <a:avLst/>
@@ -8707,7 +8752,7 @@
                 <a:ea typeface="Poppins" pitchFamily="34" charset="-122"/>
                 <a:cs typeface="Poppins" pitchFamily="34" charset="-120"/>
               </a:rPr>
-              <a:t>9</a:t>
+              <a:t>10</a:t>
             </a:r>
             <a:endParaRPr lang="en-US" sz="1200" dirty="0"/>
           </a:p>
@@ -9401,7 +9446,7 @@
                 <a:ea typeface="Poppins" pitchFamily="34" charset="-122"/>
                 <a:cs typeface="Poppins" pitchFamily="34" charset="-120"/>
               </a:rPr>
-              <a:t>12</a:t>
+              <a:t>13</a:t>
             </a:r>
             <a:endParaRPr lang="en-US" sz="1200" dirty="0"/>
           </a:p>
@@ -9686,7 +9731,7 @@
                 <a:ea typeface="Poppins" pitchFamily="34" charset="-122"/>
                 <a:cs typeface="Poppins" pitchFamily="34" charset="-120"/>
               </a:rPr>
-              <a:t>Dataset ouro com critério de aceite automático: 476/476 no gate, v0.3-gold.</a:t>
+              <a:t>Dataset ouro com critério de aceite automático: 576/576 no gate, v0.4-gold.</a:t>
             </a:r>
             <a:endParaRPr lang="en-US" sz="1200" dirty="0"/>
           </a:p>
@@ -10010,7 +10055,7 @@
                 <a:ea typeface="Poppins" pitchFamily="34" charset="-122"/>
                 <a:cs typeface="Poppins" pitchFamily="34" charset="-120"/>
               </a:rPr>
-              <a:t>Exemplo do holdout · regra cylab.python.sqli-fstring-execute</a:t>
+              <a:t>Holdout v0.4-gold · regra cylab.python.sqli-fstring-execute</a:t>
             </a:r>
             <a:endParaRPr lang="en-US" sz="1200" dirty="0"/>
           </a:p>

</xml_diff>